<commit_message>
Slide thuyết trình: thêm hai slide so với SambaMixer theo lượng thông tin và kiểm tra lại trên mọi bộ (24 slide)
Bảng NASA-L theo mức đo (tô xanh ô thấp hơn 0,96 % của SambaMixer), hình sai số theo mức thông tin
trên cả sáu trường hợp; mục lục, bảng đối chiếu đề cương và kết luận cập nhật theo. Mọi con số trên
slide vẫn được đối chiếu với lời văn của báo cáo.

Co-Authored-By: Claude Opus 5.5 <noreply@anthropic.com>
Claude-Session: https://claude.ai/code/session_01WsTkwYUpiJBnAt7LHynU5S
</commit_message>
<xml_diff>
--- a/pinn-soh/slide/Thuyet_trinh_DACN_Nhom15.pptx
+++ b/pinn-soh/slide/Thuyet_trinh_DACN_Nhom15.pptx
@@ -30,6 +30,8 @@
     <p:sldId xmlns:ns0="http://schemas.openxmlformats.org/officeDocument/2006/relationships" id="306" ns0:id="rId40"/>
     <p:sldId xmlns:ns0="http://schemas.openxmlformats.org/officeDocument/2006/relationships" id="307" ns0:id="rId41"/>
     <p:sldId xmlns:ns0="http://schemas.openxmlformats.org/officeDocument/2006/relationships" id="308" ns0:id="rId42"/>
+    <p:sldId xmlns:ns0="http://schemas.openxmlformats.org/officeDocument/2006/relationships" id="309" ns0:id="rId43"/>
+    <p:sldId xmlns:ns0="http://schemas.openxmlformats.org/officeDocument/2006/relationships" id="310" ns0:id="rId44"/>
   </p:sldIdLst>
   <p:sldSz cx="12192000" cy="6858000"/>
   <p:notesSz cx="6858000" cy="9144000"/>
@@ -1518,7 +1520,7 @@
           <a:lstStyle/>
           <a:p>
             <a:r>
-              <a:t>Nên tính nhãn theo số lần đo chứ không theo số cell: rải vài lần đo lên mọi cell tốt hơn đo kín một phần cell.</a:t>
+              <a:t>SambaMixer nhận đường xả của chính chu kỳ cần ước lượng, nên nhãn gần như nằm trong đầu vào. Em tách ba mức thông tin về chính cell: không đo, đo thưa, và biết mọi lần xả trước. Đồ án chỉ thấp hơn SambaMixer khi có thêm các lần đo của chính cell; ở mức cao nhất, cách giữ nguyên lần đo trước không cần mô hình cũng thấp hơn, nên phần thắng đến từ thông tin chứ không từ mô hình. Biến thể κ được đặt ra sau khi xem kết quả trên các bộ khác, em ghi rõ là hậu kiểm.</a:t>
             </a:r>
           </a:p>
         </p:txBody>
@@ -1588,7 +1590,7 @@
           <a:lstStyle/>
           <a:p>
             <a:r>
-              <a:t>Mọi mục của giai đoạn 1 đều đã làm. Điểm khác về hướng đi: GBDT mạnh hơn cả bốn mô hình học sâu, nên giai đoạn 2 cần giữ mô hình cây làm mốc so sánh.</a:t>
+              <a:t>Cùng các mức đo trên bốn bộ chính và trên kiểm định chéo của NASA. Giữa hai lần đo thưa, mô hình biết dung lượng giảm bao nhiêu nên tốt hơn hẳn giữ nguyên; khi đã đo mọi chu kỳ trước, thay đổi mô hình dự đoán giữa hai chu kỳ liền nhau nhiễu hơn thay đổi thật, nên giữ nguyên thắng. Giá trị của mô hình nằm ở chỗ đo thưa.</a:t>
             </a:r>
           </a:p>
         </p:txBody>
@@ -1658,7 +1660,7 @@
           <a:lstStyle/>
           <a:p>
             <a:r>
-              <a:t>Tóm lại: vật lý giúp nhiều nhất khi nhãn ít, mô hình cây vẫn là đối thủ khó nhất, và ghép hai thứ lại cho kết quả tốt nhất. Giai đoạn 2 chuyển sang khối pin nhiều cell.</a:t>
+              <a:t>Nên tính nhãn theo số lần đo chứ không theo số cell: rải vài lần đo lên mọi cell tốt hơn đo kín một phần cell.</a:t>
             </a:r>
           </a:p>
         </p:txBody>
@@ -1684,6 +1686,146 @@
 </file>
 
 <file path=ppt/notesSlides/notesSlide27.xml><?xml version="1.0" encoding="utf-8"?>
+<p:notes xmlns:a="http://schemas.openxmlformats.org/drawingml/2006/main" xmlns:p="http://schemas.openxmlformats.org/presentationml/2006/main" xmlns:r="http://schemas.openxmlformats.org/officeDocument/2006/relationships">
+  <p:cSld>
+    <p:spTree>
+      <p:nvGrpSpPr>
+        <p:cNvPr id="1" name=""/>
+        <p:cNvGrpSpPr/>
+        <p:nvPr/>
+      </p:nvGrpSpPr>
+      <p:grpSpPr>
+        <a:xfrm>
+          <a:off x="0" y="0"/>
+          <a:ext cx="0" cy="0"/>
+          <a:chOff x="0" y="0"/>
+          <a:chExt cx="0" cy="0"/>
+        </a:xfrm>
+      </p:grpSpPr>
+      <p:sp>
+        <p:nvSpPr>
+          <p:cNvPr id="2" name="Slide Image Placeholder 1"/>
+          <p:cNvSpPr>
+            <a:spLocks noGrp="1"/>
+          </p:cNvSpPr>
+          <p:nvPr>
+            <p:ph type="sldImg" idx="2"/>
+          </p:nvPr>
+        </p:nvSpPr>
+        <p:spPr/>
+      </p:sp>
+      <p:sp>
+        <p:nvSpPr>
+          <p:cNvPr id="3" name="Notes Placeholder 2"/>
+          <p:cNvSpPr>
+            <a:spLocks noGrp="1"/>
+          </p:cNvSpPr>
+          <p:nvPr>
+            <p:ph type="body" idx="3" sz="quarter"/>
+          </p:nvPr>
+        </p:nvSpPr>
+        <p:spPr/>
+        <p:txBody>
+          <a:bodyPr/>
+          <a:lstStyle/>
+          <a:p>
+            <a:r>
+              <a:t>Mọi mục của giai đoạn 1 đều đã làm. Điểm khác về hướng đi: GBDT mạnh hơn cả bốn mô hình học sâu, nên giai đoạn 2 cần giữ mô hình cây làm mốc so sánh.</a:t>
+            </a:r>
+          </a:p>
+        </p:txBody>
+      </p:sp>
+      <p:sp>
+        <p:nvSpPr>
+          <p:cNvPr id="4" name="Slide Number Placeholder 3"/>
+          <p:cNvSpPr>
+            <a:spLocks noGrp="1"/>
+          </p:cNvSpPr>
+          <p:nvPr>
+            <p:ph type="sldNum" idx="5" sz="quarter"/>
+          </p:nvPr>
+        </p:nvSpPr>
+        <p:spPr/>
+      </p:sp>
+    </p:spTree>
+  </p:cSld>
+  <p:clrMapOvr>
+    <a:masterClrMapping/>
+  </p:clrMapOvr>
+</p:notes>
+</file>
+
+<file path=ppt/notesSlides/notesSlide28.xml><?xml version="1.0" encoding="utf-8"?>
+<p:notes xmlns:a="http://schemas.openxmlformats.org/drawingml/2006/main" xmlns:p="http://schemas.openxmlformats.org/presentationml/2006/main" xmlns:r="http://schemas.openxmlformats.org/officeDocument/2006/relationships">
+  <p:cSld>
+    <p:spTree>
+      <p:nvGrpSpPr>
+        <p:cNvPr id="1" name=""/>
+        <p:cNvGrpSpPr/>
+        <p:nvPr/>
+      </p:nvGrpSpPr>
+      <p:grpSpPr>
+        <a:xfrm>
+          <a:off x="0" y="0"/>
+          <a:ext cx="0" cy="0"/>
+          <a:chOff x="0" y="0"/>
+          <a:chExt cx="0" cy="0"/>
+        </a:xfrm>
+      </p:grpSpPr>
+      <p:sp>
+        <p:nvSpPr>
+          <p:cNvPr id="2" name="Slide Image Placeholder 1"/>
+          <p:cNvSpPr>
+            <a:spLocks noGrp="1"/>
+          </p:cNvSpPr>
+          <p:nvPr>
+            <p:ph type="sldImg" idx="2"/>
+          </p:nvPr>
+        </p:nvSpPr>
+        <p:spPr/>
+      </p:sp>
+      <p:sp>
+        <p:nvSpPr>
+          <p:cNvPr id="3" name="Notes Placeholder 2"/>
+          <p:cNvSpPr>
+            <a:spLocks noGrp="1"/>
+          </p:cNvSpPr>
+          <p:nvPr>
+            <p:ph type="body" idx="3" sz="quarter"/>
+          </p:nvPr>
+        </p:nvSpPr>
+        <p:spPr/>
+        <p:txBody>
+          <a:bodyPr/>
+          <a:lstStyle/>
+          <a:p>
+            <a:r>
+              <a:t>Tóm lại: vật lý giúp nhiều nhất khi nhãn ít, mô hình cây vẫn là đối thủ khó nhất, và ghép hai thứ lại cho kết quả tốt nhất. Giai đoạn 2 chuyển sang khối pin nhiều cell.</a:t>
+            </a:r>
+          </a:p>
+        </p:txBody>
+      </p:sp>
+      <p:sp>
+        <p:nvSpPr>
+          <p:cNvPr id="4" name="Slide Number Placeholder 3"/>
+          <p:cNvSpPr>
+            <a:spLocks noGrp="1"/>
+          </p:cNvSpPr>
+          <p:nvPr>
+            <p:ph type="sldNum" idx="5" sz="quarter"/>
+          </p:nvPr>
+        </p:nvSpPr>
+        <p:spPr/>
+      </p:sp>
+    </p:spTree>
+  </p:cSld>
+  <p:clrMapOvr>
+    <a:masterClrMapping/>
+  </p:clrMapOvr>
+</p:notes>
+</file>
+
+<file path=ppt/notesSlides/notesSlide29.xml><?xml version="1.0" encoding="utf-8"?>
 <p:notes xmlns:a="http://schemas.openxmlformats.org/drawingml/2006/main" xmlns:p="http://schemas.openxmlformats.org/presentationml/2006/main" xmlns:r="http://schemas.openxmlformats.org/officeDocument/2006/relationships">
   <p:cSld>
     <p:spTree>
@@ -4267,7 +4409,7 @@
                 <a:ea typeface="Arial"/>
                 <a:cs typeface="Arial"/>
               </a:rPr>
-              <a:t>Bộ NASA và SambaMixer</a:t>
+              <a:t>Bộ NASA, SambaMixer, mức đo</a:t>
             </a:r>
           </a:p>
         </p:txBody>
@@ -7205,7 +7347,7 @@
                 <a:ea typeface="Arial"/>
                 <a:cs typeface="Arial"/>
               </a:rPr>
-              <a:t>Python, PyTorch, scikit-learn; một lệnh chạy từ dữ liệu thô tới báo cáo; 10.456 lượt huấn luyện được trình bày</a:t>
+              <a:t>Python, PyTorch, scikit-learn; một lệnh chạy từ dữ liệu thô tới báo cáo; 10.720 lượt huấn luyện được trình bày</a:t>
             </a:r>
           </a:p>
           <a:p>
@@ -14661,7 +14803,7 @@
                 <a:ea typeface="Arial"/>
                 <a:cs typeface="Arial"/>
               </a:rPr>
-              <a:t>Ngân sách đo dung lượng</a:t>
+              <a:t>NASA-L: thêm thông tin để so với SambaMixer</a:t>
             </a:r>
           </a:p>
         </p:txBody>
@@ -14745,12 +14887,798 @@
           </a:prstGeom>
         </p:spPr>
       </p:pic>
-      <p:sp>
-        <p:nvSpPr>
-          <p:cNvPr id="5" name="">
+      <p:graphicFrame>
+        <p:nvGraphicFramePr>
+          <p:cNvPr id="12" name=""/>
+          <p:cNvGraphicFramePr/>
+          <p:nvPr/>
+        </p:nvGraphicFramePr>
+        <p:xfrm>
+          <a:off x="530352" y="1280160"/>
+          <a:ext cx="6949440" cy="2514600"/>
+        </p:xfrm>
+        <a:graphic>
+          <a:graphicData uri="http://schemas.openxmlformats.org/drawingml/2006/table">
+            <a:tbl>
+              <a:tblPr/>
+              <a:tblGrid>
+                <a:gridCol w="2468880"/>
+                <a:gridCol w="822960"/>
+                <a:gridCol w="822960"/>
+                <a:gridCol w="822960"/>
+                <a:gridCol w="868680"/>
+                <a:gridCol w="1143000"/>
+              </a:tblGrid>
+              <a:tr h="502920">
+                <a:tc>
+                  <a:txBody>
+                    <a:bodyPr/>
+                    <a:lstStyle/>
+                    <a:p>
+                      <a:pPr algn="l"/>
+                      <a:r>
+                        <a:rPr sz="1300" b="1">
+                          <a:solidFill>
+                            <a:srgbClr val="FFFFFF"/>
+                          </a:solidFill>
+                          <a:latin typeface="Arial"/>
+                          <a:ea typeface="Arial"/>
+                          <a:cs typeface="Arial"/>
+                        </a:rPr>
+                        <a:t>Cách ước lượng</a:t>
+                      </a:r>
+                    </a:p>
+                  </a:txBody>
+                  <a:tcPr marL="91440" marR="91440" marT="45720" marB="45720" anchor="ctr">
+                    <a:solidFill>
+                      <a:srgbClr val="20567B"/>
+                    </a:solidFill>
+                  </a:tcPr>
+                </a:tc>
+                <a:tc>
+                  <a:txBody>
+                    <a:bodyPr/>
+                    <a:lstStyle/>
+                    <a:p>
+                      <a:pPr algn="l"/>
+                      <a:r>
+                        <a:rPr sz="1300" b="1">
+                          <a:solidFill>
+                            <a:srgbClr val="FFFFFF"/>
+                          </a:solidFill>
+                          <a:latin typeface="Arial"/>
+                          <a:ea typeface="Arial"/>
+                          <a:cs typeface="Arial"/>
+                        </a:rPr>
+                        <a:t>Không đo</a:t>
+                      </a:r>
+                    </a:p>
+                  </a:txBody>
+                  <a:tcPr marL="91440" marR="91440" marT="45720" marB="45720" anchor="ctr">
+                    <a:solidFill>
+                      <a:srgbClr val="20567B"/>
+                    </a:solidFill>
+                  </a:tcPr>
+                </a:tc>
+                <a:tc>
+                  <a:txBody>
+                    <a:bodyPr/>
+                    <a:lstStyle/>
+                    <a:p>
+                      <a:pPr algn="l"/>
+                      <a:r>
+                        <a:rPr sz="1300" b="1">
+                          <a:solidFill>
+                            <a:srgbClr val="FFFFFF"/>
+                          </a:solidFill>
+                          <a:latin typeface="Arial"/>
+                          <a:ea typeface="Arial"/>
+                          <a:cs typeface="Arial"/>
+                        </a:rPr>
+                        <a:t>Mỗi 0,2L</a:t>
+                      </a:r>
+                    </a:p>
+                  </a:txBody>
+                  <a:tcPr marL="91440" marR="91440" marT="45720" marB="45720" anchor="ctr">
+                    <a:solidFill>
+                      <a:srgbClr val="20567B"/>
+                    </a:solidFill>
+                  </a:tcPr>
+                </a:tc>
+                <a:tc>
+                  <a:txBody>
+                    <a:bodyPr/>
+                    <a:lstStyle/>
+                    <a:p>
+                      <a:pPr algn="l"/>
+                      <a:r>
+                        <a:rPr sz="1300" b="1">
+                          <a:solidFill>
+                            <a:srgbClr val="FFFFFF"/>
+                          </a:solidFill>
+                          <a:latin typeface="Arial"/>
+                          <a:ea typeface="Arial"/>
+                          <a:cs typeface="Arial"/>
+                        </a:rPr>
+                        <a:t>Mỗi 0,1L</a:t>
+                      </a:r>
+                    </a:p>
+                  </a:txBody>
+                  <a:tcPr marL="91440" marR="91440" marT="45720" marB="45720" anchor="ctr">
+                    <a:solidFill>
+                      <a:srgbClr val="20567B"/>
+                    </a:solidFill>
+                  </a:tcPr>
+                </a:tc>
+                <a:tc>
+                  <a:txBody>
+                    <a:bodyPr/>
+                    <a:lstStyle/>
+                    <a:p>
+                      <a:pPr algn="l"/>
+                      <a:r>
+                        <a:rPr sz="1300" b="1">
+                          <a:solidFill>
+                            <a:srgbClr val="FFFFFF"/>
+                          </a:solidFill>
+                          <a:latin typeface="Arial"/>
+                          <a:ea typeface="Arial"/>
+                          <a:cs typeface="Arial"/>
+                        </a:rPr>
+                        <a:t>Mỗi 0,05L</a:t>
+                      </a:r>
+                    </a:p>
+                  </a:txBody>
+                  <a:tcPr marL="91440" marR="91440" marT="45720" marB="45720" anchor="ctr">
+                    <a:solidFill>
+                      <a:srgbClr val="20567B"/>
+                    </a:solidFill>
+                  </a:tcPr>
+                </a:tc>
+                <a:tc>
+                  <a:txBody>
+                    <a:bodyPr/>
+                    <a:lstStyle/>
+                    <a:p>
+                      <a:pPr algn="l"/>
+                      <a:r>
+                        <a:rPr sz="1300" b="1">
+                          <a:solidFill>
+                            <a:srgbClr val="FFFFFF"/>
+                          </a:solidFill>
+                          <a:latin typeface="Arial"/>
+                          <a:ea typeface="Arial"/>
+                          <a:cs typeface="Arial"/>
+                        </a:rPr>
+                        <a:t>Mọi lần xả trước</a:t>
+                      </a:r>
+                    </a:p>
+                  </a:txBody>
+                  <a:tcPr marL="91440" marR="91440" marT="45720" marB="45720" anchor="ctr">
+                    <a:solidFill>
+                      <a:srgbClr val="20567B"/>
+                    </a:solidFill>
+                  </a:tcPr>
+                </a:tc>
+              </a:tr>
+              <a:tr h="502920">
+                <a:tc>
+                  <a:txBody>
+                    <a:bodyPr/>
+                    <a:lstStyle/>
+                    <a:p>
+                      <a:pPr algn="l"/>
+                      <a:r>
+                        <a:rPr sz="1300" b="0">
+                          <a:solidFill>
+                            <a:srgbClr val="163047"/>
+                          </a:solidFill>
+                          <a:latin typeface="Arial"/>
+                          <a:ea typeface="Arial"/>
+                          <a:cs typeface="Arial"/>
+                        </a:rPr>
+                        <a:t>PINN-lai + Kalman</a:t>
+                      </a:r>
+                    </a:p>
+                  </a:txBody>
+                  <a:tcPr marL="91440" marR="91440" marT="45720" marB="45720" anchor="ctr">
+                    <a:solidFill>
+                      <a:srgbClr val="EAF3F7"/>
+                    </a:solidFill>
+                  </a:tcPr>
+                </a:tc>
+                <a:tc>
+                  <a:txBody>
+                    <a:bodyPr/>
+                    <a:lstStyle/>
+                    <a:p>
+                      <a:pPr algn="l"/>
+                      <a:r>
+                        <a:rPr sz="1300" b="0">
+                          <a:solidFill>
+                            <a:srgbClr val="163047"/>
+                          </a:solidFill>
+                          <a:latin typeface="Arial"/>
+                          <a:ea typeface="Arial"/>
+                          <a:cs typeface="Arial"/>
+                        </a:rPr>
+                        <a:t>2,54</a:t>
+                      </a:r>
+                    </a:p>
+                  </a:txBody>
+                  <a:tcPr marL="91440" marR="91440" marT="45720" marB="45720" anchor="ctr">
+                    <a:solidFill>
+                      <a:srgbClr val="EAF3F7"/>
+                    </a:solidFill>
+                  </a:tcPr>
+                </a:tc>
+                <a:tc>
+                  <a:txBody>
+                    <a:bodyPr/>
+                    <a:lstStyle/>
+                    <a:p>
+                      <a:pPr algn="l"/>
+                      <a:r>
+                        <a:rPr sz="1300" b="0">
+                          <a:solidFill>
+                            <a:srgbClr val="163047"/>
+                          </a:solidFill>
+                          <a:latin typeface="Arial"/>
+                          <a:ea typeface="Arial"/>
+                          <a:cs typeface="Arial"/>
+                        </a:rPr>
+                        <a:t>1,89</a:t>
+                      </a:r>
+                    </a:p>
+                  </a:txBody>
+                  <a:tcPr marL="91440" marR="91440" marT="45720" marB="45720" anchor="ctr">
+                    <a:solidFill>
+                      <a:srgbClr val="EAF3F7"/>
+                    </a:solidFill>
+                  </a:tcPr>
+                </a:tc>
+                <a:tc>
+                  <a:txBody>
+                    <a:bodyPr/>
+                    <a:lstStyle/>
+                    <a:p>
+                      <a:pPr algn="l"/>
+                      <a:r>
+                        <a:rPr sz="1300" b="0">
+                          <a:solidFill>
+                            <a:srgbClr val="163047"/>
+                          </a:solidFill>
+                          <a:latin typeface="Arial"/>
+                          <a:ea typeface="Arial"/>
+                          <a:cs typeface="Arial"/>
+                        </a:rPr>
+                        <a:t>1,58</a:t>
+                      </a:r>
+                    </a:p>
+                  </a:txBody>
+                  <a:tcPr marL="91440" marR="91440" marT="45720" marB="45720" anchor="ctr">
+                    <a:solidFill>
+                      <a:srgbClr val="EAF3F7"/>
+                    </a:solidFill>
+                  </a:tcPr>
+                </a:tc>
+                <a:tc>
+                  <a:txBody>
+                    <a:bodyPr/>
+                    <a:lstStyle/>
+                    <a:p>
+                      <a:pPr algn="l"/>
+                      <a:r>
+                        <a:rPr sz="1300" b="0">
+                          <a:solidFill>
+                            <a:srgbClr val="163047"/>
+                          </a:solidFill>
+                          <a:latin typeface="Arial"/>
+                          <a:ea typeface="Arial"/>
+                          <a:cs typeface="Arial"/>
+                        </a:rPr>
+                        <a:t>1,08</a:t>
+                      </a:r>
+                    </a:p>
+                  </a:txBody>
+                  <a:tcPr marL="91440" marR="91440" marT="45720" marB="45720" anchor="ctr">
+                    <a:solidFill>
+                      <a:srgbClr val="EAF3F7"/>
+                    </a:solidFill>
+                  </a:tcPr>
+                </a:tc>
+                <a:tc>
+                  <a:txBody>
+                    <a:bodyPr/>
+                    <a:lstStyle/>
+                    <a:p>
+                      <a:pPr algn="l"/>
+                      <a:r>
+                        <a:rPr sz="1300" b="1">
+                          <a:solidFill>
+                            <a:srgbClr val="0D6E56"/>
+                          </a:solidFill>
+                          <a:latin typeface="Arial"/>
+                          <a:ea typeface="Arial"/>
+                          <a:cs typeface="Arial"/>
+                        </a:rPr>
+                        <a:t>0,80</a:t>
+                      </a:r>
+                    </a:p>
+                  </a:txBody>
+                  <a:tcPr marL="91440" marR="91440" marT="45720" marB="45720" anchor="ctr">
+                    <a:solidFill>
+                      <a:srgbClr val="EAF3F7"/>
+                    </a:solidFill>
+                  </a:tcPr>
+                </a:tc>
+              </a:tr>
+              <a:tr h="502920">
+                <a:tc>
+                  <a:txBody>
+                    <a:bodyPr/>
+                    <a:lstStyle/>
+                    <a:p>
+                      <a:pPr algn="l"/>
+                      <a:r>
+                        <a:rPr sz="1300" b="0">
+                          <a:solidFill>
+                            <a:srgbClr val="163047"/>
+                          </a:solidFill>
+                          <a:latin typeface="Arial"/>
+                          <a:ea typeface="Arial"/>
+                          <a:cs typeface="Arial"/>
+                        </a:rPr>
+                        <a:t>PINN-lai + Kalman, κ (hậu kiểm)</a:t>
+                      </a:r>
+                    </a:p>
+                  </a:txBody>
+                  <a:tcPr marL="91440" marR="91440" marT="45720" marB="45720" anchor="ctr">
+                    <a:solidFill>
+                      <a:srgbClr val="FFFFFF"/>
+                    </a:solidFill>
+                  </a:tcPr>
+                </a:tc>
+                <a:tc>
+                  <a:txBody>
+                    <a:bodyPr/>
+                    <a:lstStyle/>
+                    <a:p>
+                      <a:pPr algn="l"/>
+                      <a:r>
+                        <a:rPr sz="1300" b="0">
+                          <a:solidFill>
+                            <a:srgbClr val="163047"/>
+                          </a:solidFill>
+                          <a:latin typeface="Arial"/>
+                          <a:ea typeface="Arial"/>
+                          <a:cs typeface="Arial"/>
+                        </a:rPr>
+                        <a:t>–</a:t>
+                      </a:r>
+                    </a:p>
+                  </a:txBody>
+                  <a:tcPr marL="91440" marR="91440" marT="45720" marB="45720" anchor="ctr">
+                    <a:solidFill>
+                      <a:srgbClr val="FFFFFF"/>
+                    </a:solidFill>
+                  </a:tcPr>
+                </a:tc>
+                <a:tc>
+                  <a:txBody>
+                    <a:bodyPr/>
+                    <a:lstStyle/>
+                    <a:p>
+                      <a:pPr algn="l"/>
+                      <a:r>
+                        <a:rPr sz="1300" b="0">
+                          <a:solidFill>
+                            <a:srgbClr val="163047"/>
+                          </a:solidFill>
+                          <a:latin typeface="Arial"/>
+                          <a:ea typeface="Arial"/>
+                          <a:cs typeface="Arial"/>
+                        </a:rPr>
+                        <a:t>1,64</a:t>
+                      </a:r>
+                    </a:p>
+                  </a:txBody>
+                  <a:tcPr marL="91440" marR="91440" marT="45720" marB="45720" anchor="ctr">
+                    <a:solidFill>
+                      <a:srgbClr val="FFFFFF"/>
+                    </a:solidFill>
+                  </a:tcPr>
+                </a:tc>
+                <a:tc>
+                  <a:txBody>
+                    <a:bodyPr/>
+                    <a:lstStyle/>
+                    <a:p>
+                      <a:pPr algn="l"/>
+                      <a:r>
+                        <a:rPr sz="1300" b="0">
+                          <a:solidFill>
+                            <a:srgbClr val="163047"/>
+                          </a:solidFill>
+                          <a:latin typeface="Arial"/>
+                          <a:ea typeface="Arial"/>
+                          <a:cs typeface="Arial"/>
+                        </a:rPr>
+                        <a:t>1,32</a:t>
+                      </a:r>
+                    </a:p>
+                  </a:txBody>
+                  <a:tcPr marL="91440" marR="91440" marT="45720" marB="45720" anchor="ctr">
+                    <a:solidFill>
+                      <a:srgbClr val="FFFFFF"/>
+                    </a:solidFill>
+                  </a:tcPr>
+                </a:tc>
+                <a:tc>
+                  <a:txBody>
+                    <a:bodyPr/>
+                    <a:lstStyle/>
+                    <a:p>
+                      <a:pPr algn="l"/>
+                      <a:r>
+                        <a:rPr sz="1300" b="1">
+                          <a:solidFill>
+                            <a:srgbClr val="0D6E56"/>
+                          </a:solidFill>
+                          <a:latin typeface="Arial"/>
+                          <a:ea typeface="Arial"/>
+                          <a:cs typeface="Arial"/>
+                        </a:rPr>
+                        <a:t>0,82</a:t>
+                      </a:r>
+                    </a:p>
+                  </a:txBody>
+                  <a:tcPr marL="91440" marR="91440" marT="45720" marB="45720" anchor="ctr">
+                    <a:solidFill>
+                      <a:srgbClr val="FFFFFF"/>
+                    </a:solidFill>
+                  </a:tcPr>
+                </a:tc>
+                <a:tc>
+                  <a:txBody>
+                    <a:bodyPr/>
+                    <a:lstStyle/>
+                    <a:p>
+                      <a:pPr algn="l"/>
+                      <a:r>
+                        <a:rPr sz="1300" b="1">
+                          <a:solidFill>
+                            <a:srgbClr val="0D6E56"/>
+                          </a:solidFill>
+                          <a:latin typeface="Arial"/>
+                          <a:ea typeface="Arial"/>
+                          <a:cs typeface="Arial"/>
+                        </a:rPr>
+                        <a:t>0,64</a:t>
+                      </a:r>
+                    </a:p>
+                  </a:txBody>
+                  <a:tcPr marL="91440" marR="91440" marT="45720" marB="45720" anchor="ctr">
+                    <a:solidFill>
+                      <a:srgbClr val="FFFFFF"/>
+                    </a:solidFill>
+                  </a:tcPr>
+                </a:tc>
+              </a:tr>
+              <a:tr h="502920">
+                <a:tc>
+                  <a:txBody>
+                    <a:bodyPr/>
+                    <a:lstStyle/>
+                    <a:p>
+                      <a:pPr algn="l"/>
+                      <a:r>
+                        <a:rPr sz="1300" b="0">
+                          <a:solidFill>
+                            <a:srgbClr val="163047"/>
+                          </a:solidFill>
+                          <a:latin typeface="Arial"/>
+                          <a:ea typeface="Arial"/>
+                          <a:cs typeface="Arial"/>
+                        </a:rPr>
+                        <a:t>Gần nhất</a:t>
+                      </a:r>
+                    </a:p>
+                  </a:txBody>
+                  <a:tcPr marL="91440" marR="91440" marT="45720" marB="45720" anchor="ctr">
+                    <a:solidFill>
+                      <a:srgbClr val="EAF3F7"/>
+                    </a:solidFill>
+                  </a:tcPr>
+                </a:tc>
+                <a:tc>
+                  <a:txBody>
+                    <a:bodyPr/>
+                    <a:lstStyle/>
+                    <a:p>
+                      <a:pPr algn="l"/>
+                      <a:r>
+                        <a:rPr sz="1300" b="0">
+                          <a:solidFill>
+                            <a:srgbClr val="163047"/>
+                          </a:solidFill>
+                          <a:latin typeface="Arial"/>
+                          <a:ea typeface="Arial"/>
+                          <a:cs typeface="Arial"/>
+                        </a:rPr>
+                        <a:t>–</a:t>
+                      </a:r>
+                    </a:p>
+                  </a:txBody>
+                  <a:tcPr marL="91440" marR="91440" marT="45720" marB="45720" anchor="ctr">
+                    <a:solidFill>
+                      <a:srgbClr val="EAF3F7"/>
+                    </a:solidFill>
+                  </a:tcPr>
+                </a:tc>
+                <a:tc>
+                  <a:txBody>
+                    <a:bodyPr/>
+                    <a:lstStyle/>
+                    <a:p>
+                      <a:pPr algn="l"/>
+                      <a:r>
+                        <a:rPr sz="1300" b="0">
+                          <a:solidFill>
+                            <a:srgbClr val="163047"/>
+                          </a:solidFill>
+                          <a:latin typeface="Arial"/>
+                          <a:ea typeface="Arial"/>
+                          <a:cs typeface="Arial"/>
+                        </a:rPr>
+                        <a:t>2,18</a:t>
+                      </a:r>
+                    </a:p>
+                  </a:txBody>
+                  <a:tcPr marL="91440" marR="91440" marT="45720" marB="45720" anchor="ctr">
+                    <a:solidFill>
+                      <a:srgbClr val="EAF3F7"/>
+                    </a:solidFill>
+                  </a:tcPr>
+                </a:tc>
+                <a:tc>
+                  <a:txBody>
+                    <a:bodyPr/>
+                    <a:lstStyle/>
+                    <a:p>
+                      <a:pPr algn="l"/>
+                      <a:r>
+                        <a:rPr sz="1300" b="0">
+                          <a:solidFill>
+                            <a:srgbClr val="163047"/>
+                          </a:solidFill>
+                          <a:latin typeface="Arial"/>
+                          <a:ea typeface="Arial"/>
+                          <a:cs typeface="Arial"/>
+                        </a:rPr>
+                        <a:t>1,57</a:t>
+                      </a:r>
+                    </a:p>
+                  </a:txBody>
+                  <a:tcPr marL="91440" marR="91440" marT="45720" marB="45720" anchor="ctr">
+                    <a:solidFill>
+                      <a:srgbClr val="EAF3F7"/>
+                    </a:solidFill>
+                  </a:tcPr>
+                </a:tc>
+                <a:tc>
+                  <a:txBody>
+                    <a:bodyPr/>
+                    <a:lstStyle/>
+                    <a:p>
+                      <a:pPr algn="l"/>
+                      <a:r>
+                        <a:rPr sz="1300" b="0">
+                          <a:solidFill>
+                            <a:srgbClr val="163047"/>
+                          </a:solidFill>
+                          <a:latin typeface="Arial"/>
+                          <a:ea typeface="Arial"/>
+                          <a:cs typeface="Arial"/>
+                        </a:rPr>
+                        <a:t>1,19</a:t>
+                      </a:r>
+                    </a:p>
+                  </a:txBody>
+                  <a:tcPr marL="91440" marR="91440" marT="45720" marB="45720" anchor="ctr">
+                    <a:solidFill>
+                      <a:srgbClr val="EAF3F7"/>
+                    </a:solidFill>
+                  </a:tcPr>
+                </a:tc>
+                <a:tc>
+                  <a:txBody>
+                    <a:bodyPr/>
+                    <a:lstStyle/>
+                    <a:p>
+                      <a:pPr algn="l"/>
+                      <a:r>
+                        <a:rPr sz="1300" b="1">
+                          <a:solidFill>
+                            <a:srgbClr val="0D6E56"/>
+                          </a:solidFill>
+                          <a:latin typeface="Arial"/>
+                          <a:ea typeface="Arial"/>
+                          <a:cs typeface="Arial"/>
+                        </a:rPr>
+                        <a:t>0,75</a:t>
+                      </a:r>
+                    </a:p>
+                  </a:txBody>
+                  <a:tcPr marL="91440" marR="91440" marT="45720" marB="45720" anchor="ctr">
+                    <a:solidFill>
+                      <a:srgbClr val="EAF3F7"/>
+                    </a:solidFill>
+                  </a:tcPr>
+                </a:tc>
+              </a:tr>
+              <a:tr h="502920">
+                <a:tc>
+                  <a:txBody>
+                    <a:bodyPr/>
+                    <a:lstStyle/>
+                    <a:p>
+                      <a:pPr algn="l"/>
+                      <a:r>
+                        <a:rPr sz="1300" b="0">
+                          <a:solidFill>
+                            <a:srgbClr val="163047"/>
+                          </a:solidFill>
+                          <a:latin typeface="Arial"/>
+                          <a:ea typeface="Arial"/>
+                          <a:cs typeface="Arial"/>
+                        </a:rPr>
+                        <a:t>Giữ nguyên (không mô hình)</a:t>
+                      </a:r>
+                    </a:p>
+                  </a:txBody>
+                  <a:tcPr marL="91440" marR="91440" marT="45720" marB="45720" anchor="ctr">
+                    <a:solidFill>
+                      <a:srgbClr val="FFFFFF"/>
+                    </a:solidFill>
+                  </a:tcPr>
+                </a:tc>
+                <a:tc>
+                  <a:txBody>
+                    <a:bodyPr/>
+                    <a:lstStyle/>
+                    <a:p>
+                      <a:pPr algn="l"/>
+                      <a:r>
+                        <a:rPr sz="1300" b="0">
+                          <a:solidFill>
+                            <a:srgbClr val="163047"/>
+                          </a:solidFill>
+                          <a:latin typeface="Arial"/>
+                          <a:ea typeface="Arial"/>
+                          <a:cs typeface="Arial"/>
+                        </a:rPr>
+                        <a:t>–</a:t>
+                      </a:r>
+                    </a:p>
+                  </a:txBody>
+                  <a:tcPr marL="91440" marR="91440" marT="45720" marB="45720" anchor="ctr">
+                    <a:solidFill>
+                      <a:srgbClr val="FFFFFF"/>
+                    </a:solidFill>
+                  </a:tcPr>
+                </a:tc>
+                <a:tc>
+                  <a:txBody>
+                    <a:bodyPr/>
+                    <a:lstStyle/>
+                    <a:p>
+                      <a:pPr algn="l"/>
+                      <a:r>
+                        <a:rPr sz="1300" b="0">
+                          <a:solidFill>
+                            <a:srgbClr val="163047"/>
+                          </a:solidFill>
+                          <a:latin typeface="Arial"/>
+                          <a:ea typeface="Arial"/>
+                          <a:cs typeface="Arial"/>
+                        </a:rPr>
+                        <a:t>2,54</a:t>
+                      </a:r>
+                    </a:p>
+                  </a:txBody>
+                  <a:tcPr marL="91440" marR="91440" marT="45720" marB="45720" anchor="ctr">
+                    <a:solidFill>
+                      <a:srgbClr val="FFFFFF"/>
+                    </a:solidFill>
+                  </a:tcPr>
+                </a:tc>
+                <a:tc>
+                  <a:txBody>
+                    <a:bodyPr/>
+                    <a:lstStyle/>
+                    <a:p>
+                      <a:pPr algn="l"/>
+                      <a:r>
+                        <a:rPr sz="1300" b="0">
+                          <a:solidFill>
+                            <a:srgbClr val="163047"/>
+                          </a:solidFill>
+                          <a:latin typeface="Arial"/>
+                          <a:ea typeface="Arial"/>
+                          <a:cs typeface="Arial"/>
+                        </a:rPr>
+                        <a:t>1,48</a:t>
+                      </a:r>
+                    </a:p>
+                  </a:txBody>
+                  <a:tcPr marL="91440" marR="91440" marT="45720" marB="45720" anchor="ctr">
+                    <a:solidFill>
+                      <a:srgbClr val="FFFFFF"/>
+                    </a:solidFill>
+                  </a:tcPr>
+                </a:tc>
+                <a:tc>
+                  <a:txBody>
+                    <a:bodyPr/>
+                    <a:lstStyle/>
+                    <a:p>
+                      <a:pPr algn="l"/>
+                      <a:r>
+                        <a:rPr sz="1300" b="0">
+                          <a:solidFill>
+                            <a:srgbClr val="163047"/>
+                          </a:solidFill>
+                          <a:latin typeface="Arial"/>
+                          <a:ea typeface="Arial"/>
+                          <a:cs typeface="Arial"/>
+                        </a:rPr>
+                        <a:t>0,99</a:t>
+                      </a:r>
+                    </a:p>
+                  </a:txBody>
+                  <a:tcPr marL="91440" marR="91440" marT="45720" marB="45720" anchor="ctr">
+                    <a:solidFill>
+                      <a:srgbClr val="FFFFFF"/>
+                    </a:solidFill>
+                  </a:tcPr>
+                </a:tc>
+                <a:tc>
+                  <a:txBody>
+                    <a:bodyPr/>
+                    <a:lstStyle/>
+                    <a:p>
+                      <a:pPr algn="l"/>
+                      <a:r>
+                        <a:rPr sz="1300" b="1">
+                          <a:solidFill>
+                            <a:srgbClr val="0D6E56"/>
+                          </a:solidFill>
+                          <a:latin typeface="Arial"/>
+                          <a:ea typeface="Arial"/>
+                          <a:cs typeface="Arial"/>
+                        </a:rPr>
+                        <a:t>0,60</a:t>
+                      </a:r>
+                    </a:p>
+                  </a:txBody>
+                  <a:tcPr marL="91440" marR="91440" marT="45720" marB="45720" anchor="ctr">
+                    <a:solidFill>
+                      <a:srgbClr val="FFFFFF"/>
+                    </a:solidFill>
+                  </a:tcPr>
+                </a:tc>
+              </a:tr>
+            </a:tbl>
+          </a:graphicData>
+        </a:graphic>
+      </p:graphicFrame>
+      <p:sp>
+        <p:nvSpPr>
+          <p:cNvPr id="6" name="">
             <a:extLst>
               <a:ext uri="{FF2B5EF4-FFF2-40B4-BE49-F238E27FC236}">
-                <a16:creationId xmlns:a16="http://schemas.microsoft.com/office/drawing/2014/main" id="{61ADA485-A3D9-4801-AF20-EEDA600A294B}"/>
+                <a16:creationId xmlns:a16="http://schemas.microsoft.com/office/drawing/2014/main" id="{EE2ABE15-3EEB-4EA0-9CA6-5CA037A62878}"/>
               </a:ext>
             </a:extLst>
           </p:cNvPr>
@@ -14761,50 +15689,50 @@
         </p:nvSpPr>
         <p:spPr>
           <a:xfrm>
-            <a:off x="521207" y="1143000"/>
-            <a:ext cx="6949440" cy="5074920"/>
-          </a:xfrm>
-          <a:prstGeom prst="rect">
-            <a:avLst/>
-          </a:prstGeom>
-          <a:solidFill>
-            <a:srgbClr val="FFFFFF"/>
-          </a:solidFill>
-          <a:ln w="9525">
-            <a:solidFill>
-              <a:srgbClr val="A7BAC7"/>
-            </a:solidFill>
+            <a:off x="621792" y="3977639"/>
+            <a:ext cx="6766560" cy="1280160"/>
+          </a:xfrm>
+          <a:prstGeom prst="rect">
+            <a:avLst/>
+          </a:prstGeom>
+          <a:noFill/>
+          <a:ln w="0">
+            <a:noFill/>
           </a:ln>
         </p:spPr>
         <p:txBody>
-          <a:bodyPr/>
-          <a:p/>
-        </p:txBody>
-      </p:sp>
-      <p:pic>
-        <p:nvPicPr>
-          <p:cNvPr id="16" name="Picture 15" descr="fig_e28_budget.png"/>
-          <p:cNvPicPr>
-            <a:picLocks noChangeAspect="1"/>
-          </p:cNvPicPr>
-          <p:nvPr/>
-        </p:nvPicPr>
-        <p:blipFill>
-          <a:blip r:embed="rId3"/>
-          <a:stretch>
-            <a:fillRect/>
-          </a:stretch>
-        </p:blipFill>
-        <p:spPr>
-          <a:xfrm>
-            <a:off x="630936" y="1261388"/>
-            <a:ext cx="6729982" cy="4838144"/>
-          </a:xfrm>
-          <a:prstGeom prst="rect">
-            <a:avLst/>
-          </a:prstGeom>
-        </p:spPr>
-      </p:pic>
+          <a:bodyPr lIns="0" tIns="0" rIns="0" bIns="0" anchor="t">
+            <a:noAutofit/>
+          </a:bodyPr>
+          <a:lstStyle/>
+          <a:p>
+            <a:pPr algn="l">
+              <a:spcAft>
+                <a:spcPts val="585"/>
+              </a:spcAft>
+              <a:defRPr sz="1300" b="0">
+                <a:solidFill>
+                  <a:srgbClr val="163047"/>
+                </a:solidFill>
+                <a:latin typeface="Arial"/>
+                <a:ea typeface="Arial"/>
+                <a:cs typeface="Arial"/>
+              </a:defRPr>
+            </a:pPr>
+            <a:r>
+              <a:rPr sz="1300" b="0">
+                <a:solidFill>
+                  <a:srgbClr val="163047"/>
+                </a:solidFill>
+                <a:latin typeface="Arial"/>
+                <a:ea typeface="Arial"/>
+                <a:cs typeface="Arial"/>
+              </a:rPr>
+              <a:t>MAE trung bình ba cell đánh giá (% SOH), 24 cột đầu vào, 3 hạt giống; ở mức đo thưa, sai số tính trên các chu kỳ không được đo. Màu xanh: thấp hơn 0,96 % của SambaMixer.</a:t>
+            </a:r>
+          </a:p>
+        </p:txBody>
+      </p:sp>
       <p:sp>
         <p:nvSpPr>
           <p:cNvPr id="5" name="">
@@ -14821,8 +15749,8 @@
         </p:nvSpPr>
         <p:spPr>
           <a:xfrm>
-            <a:off x="7726679" y="1325880"/>
-            <a:ext cx="3931920" cy="329184"/>
+            <a:off x="7818120" y="1280160"/>
+            <a:ext cx="3840480" cy="329184"/>
           </a:xfrm>
           <a:prstGeom prst="rect">
             <a:avLst/>
@@ -14839,7 +15767,7 @@
           <a:lstStyle/>
           <a:p>
             <a:pPr algn="l">
-              <a:defRPr sz="1700" b="1">
+              <a:defRPr sz="1600" b="1">
                 <a:solidFill>
                   <a:srgbClr val="20567B"/>
                 </a:solidFill>
@@ -14849,7 +15777,7 @@
               </a:defRPr>
             </a:pPr>
             <a:r>
-              <a:rPr sz="1700" b="1">
+              <a:rPr sz="1600" b="1">
                 <a:solidFill>
                   <a:srgbClr val="20567B"/>
                 </a:solidFill>
@@ -14857,7 +15785,7 @@
                 <a:ea typeface="Arial"/>
                 <a:cs typeface="Arial"/>
               </a:rPr>
-              <a:t>Đo thưa mọi cell</a:t>
+              <a:t>Không đo cell</a:t>
             </a:r>
           </a:p>
         </p:txBody>
@@ -14878,8 +15806,8 @@
         </p:nvSpPr>
         <p:spPr>
           <a:xfrm>
-            <a:off x="7726679" y="1709928"/>
-            <a:ext cx="3931920" cy="1025652"/>
+            <a:off x="7818120" y="1664207"/>
+            <a:ext cx="3840480" cy="962152"/>
           </a:xfrm>
           <a:prstGeom prst="rect">
             <a:avLst/>
@@ -14897,9 +15825,9 @@
           <a:p>
             <a:pPr algn="l">
               <a:spcAft>
-                <a:spcPts val="675"/>
+                <a:spcPts val="630"/>
               </a:spcAft>
-              <a:defRPr sz="1500" b="0">
+              <a:defRPr sz="1400" b="0">
                 <a:solidFill>
                   <a:srgbClr val="163047"/>
                 </a:solidFill>
@@ -14909,7 +15837,7 @@
               </a:defRPr>
             </a:pPr>
             <a:r>
-              <a:rPr sz="1500" b="0">
+              <a:rPr sz="1400" b="0">
                 <a:solidFill>
                   <a:srgbClr val="163047"/>
                 </a:solidFill>
@@ -14917,7 +15845,7 @@
                 <a:ea typeface="Arial"/>
                 <a:cs typeface="Arial"/>
               </a:rPr>
-              <a:t>Chỉ đo 1,2–6,0 % số chu kỳ, PINN-lai có sai số bằng 0,85–0,93 lần gắn nhãn đầy đủ cho 30 % số cell và 0,97–1,05 lần khi gắn cho 70 %.</a:t>
+              <a:t>Thêm 7 đặc trưng của cả lần sạc: PINN-lai 4,12 → 2,52 %, LSTM 2,16 %, vẫn gấp 2,2 lần SambaMixer (0,96 %, dùng chính lần xả).</a:t>
             </a:r>
           </a:p>
         </p:txBody>
@@ -14938,8 +15866,8 @@
         </p:nvSpPr>
         <p:spPr>
           <a:xfrm>
-            <a:off x="7726679" y="2845307"/>
-            <a:ext cx="3931920" cy="329184"/>
+            <a:off x="7818120" y="2736087"/>
+            <a:ext cx="3840480" cy="329184"/>
           </a:xfrm>
           <a:prstGeom prst="rect">
             <a:avLst/>
@@ -14956,7 +15884,7 @@
           <a:lstStyle/>
           <a:p>
             <a:pPr algn="l">
-              <a:defRPr sz="1700" b="1">
+              <a:defRPr sz="1600" b="1">
                 <a:solidFill>
                   <a:srgbClr val="20567B"/>
                 </a:solidFill>
@@ -14966,7 +15894,7 @@
               </a:defRPr>
             </a:pPr>
             <a:r>
-              <a:rPr sz="1700" b="1">
+              <a:rPr sz="1600" b="1">
                 <a:solidFill>
                   <a:srgbClr val="20567B"/>
                 </a:solidFill>
@@ -14974,7 +15902,7 @@
                 <a:ea typeface="Arial"/>
                 <a:cs typeface="Arial"/>
               </a:rPr>
-              <a:t>Đo cả cell mới</a:t>
+              <a:t>Đo thêm cell</a:t>
             </a:r>
           </a:p>
         </p:txBody>
@@ -14995,8 +15923,8 @@
         </p:nvSpPr>
         <p:spPr>
           <a:xfrm>
-            <a:off x="7726679" y="3229355"/>
-            <a:ext cx="3931920" cy="787527"/>
+            <a:off x="7818120" y="3120135"/>
+            <a:ext cx="3840480" cy="1184402"/>
           </a:xfrm>
           <a:prstGeom prst="rect">
             <a:avLst/>
@@ -15014,9 +15942,9 @@
           <a:p>
             <a:pPr algn="l">
               <a:spcAft>
-                <a:spcPts val="675"/>
+                <a:spcPts val="630"/>
               </a:spcAft>
-              <a:defRPr sz="1500" b="0">
+              <a:defRPr sz="1400" b="0">
                 <a:solidFill>
                   <a:srgbClr val="163047"/>
                 </a:solidFill>
@@ -15026,7 +15954,7 @@
               </a:defRPr>
             </a:pPr>
             <a:r>
-              <a:rPr sz="1500" b="0">
+              <a:rPr sz="1400" b="0">
                 <a:solidFill>
                   <a:srgbClr val="163047"/>
                 </a:solidFill>
@@ -15034,7 +15962,7 @@
                 <a:ea typeface="Arial"/>
                 <a:cs typeface="Arial"/>
               </a:rPr>
-              <a:t>Cập nhật bằng bộ lọc Kalman, sai số còn 0,34–0,77 lần GBDT học với 70 % cell có nhãn.</a:t>
+              <a:t>Bộ lọc Kalman chỉ thấp hơn SambaMixer khi biết mọi lần xả trước (0,80 %); giữ nguyên lần đo trước cũng đạt 0,60 %. Biến thể κ: 0,82 % khi đo mỗi 0,05L, chưa lặp lại trên kiểm định chéo.</a:t>
             </a:r>
           </a:p>
         </p:txBody>
@@ -15152,7 +16080,7 @@
                 <a:ea typeface="Arial"/>
                 <a:cs typeface="Arial"/>
               </a:rPr>
-              <a:t>Đối chiếu với đề cương (giai đoạn 1)</a:t>
+              <a:t>Kiểm tra lại trên mọi bộ: sai số theo lượng thông tin đo được</a:t>
             </a:r>
           </a:p>
         </p:txBody>
@@ -15210,6 +16138,816 @@
                 <a:cs typeface="Arial"/>
               </a:rPr>
               <a:t>20</a:t>
+            </a:r>
+          </a:p>
+        </p:txBody>
+      </p:sp>
+      <p:pic>
+        <p:nvPicPr>
+          <p:cNvPr id="15" name=""/>
+          <p:cNvPicPr>
+            <a:picLocks noChangeAspect="1"/>
+          </p:cNvPicPr>
+          <p:nvPr/>
+        </p:nvPicPr>
+        <p:blipFill>
+          <a:blip r:embed="rId2"/>
+          <a:stretch/>
+        </p:blipFill>
+        <p:spPr>
+          <a:xfrm>
+            <a:off x="11696700" y="6384974"/>
+            <a:ext cx="285750" cy="260252"/>
+          </a:xfrm>
+          <a:prstGeom prst="rect">
+            <a:avLst/>
+          </a:prstGeom>
+        </p:spPr>
+      </p:pic>
+      <p:sp>
+        <p:nvSpPr>
+          <p:cNvPr id="5" name="">
+            <a:extLst>
+              <a:ext uri="{FF2B5EF4-FFF2-40B4-BE49-F238E27FC236}">
+                <a16:creationId xmlns:a16="http://schemas.microsoft.com/office/drawing/2014/main" id="{61ADA485-A3D9-4801-AF20-EEDA600A294B}"/>
+              </a:ext>
+            </a:extLst>
+          </p:cNvPr>
+          <p:cNvSpPr>
+            <a:spLocks noGrp="1"/>
+          </p:cNvSpPr>
+          <p:nvPr/>
+        </p:nvSpPr>
+        <p:spPr>
+          <a:xfrm>
+            <a:off x="521207" y="1188720"/>
+            <a:ext cx="11146536" cy="4297680"/>
+          </a:xfrm>
+          <a:prstGeom prst="rect">
+            <a:avLst/>
+          </a:prstGeom>
+          <a:solidFill>
+            <a:srgbClr val="FFFFFF"/>
+          </a:solidFill>
+          <a:ln w="9525">
+            <a:solidFill>
+              <a:srgbClr val="A7BAC7"/>
+            </a:solidFill>
+          </a:ln>
+        </p:spPr>
+        <p:txBody>
+          <a:bodyPr/>
+          <a:p/>
+        </p:txBody>
+      </p:sp>
+      <p:pic>
+        <p:nvPicPr>
+          <p:cNvPr id="16" name="Picture 15" descr="fig_e31_tiers.png"/>
+          <p:cNvPicPr>
+            <a:picLocks noChangeAspect="1"/>
+          </p:cNvPicPr>
+          <p:nvPr/>
+        </p:nvPicPr>
+        <p:blipFill>
+          <a:blip r:embed="rId3"/>
+          <a:stretch>
+            <a:fillRect/>
+          </a:stretch>
+        </p:blipFill>
+        <p:spPr>
+          <a:xfrm>
+            <a:off x="2626165" y="1298448"/>
+            <a:ext cx="6936622" cy="4078223"/>
+          </a:xfrm>
+          <a:prstGeom prst="rect">
+            <a:avLst/>
+          </a:prstGeom>
+        </p:spPr>
+      </p:pic>
+      <p:sp>
+        <p:nvSpPr>
+          <p:cNvPr id="6" name="">
+            <a:extLst>
+              <a:ext uri="{FF2B5EF4-FFF2-40B4-BE49-F238E27FC236}">
+                <a16:creationId xmlns:a16="http://schemas.microsoft.com/office/drawing/2014/main" id="{EE2ABE15-3EEB-4EA0-9CA6-5CA037A62878}"/>
+              </a:ext>
+            </a:extLst>
+          </p:cNvPr>
+          <p:cNvSpPr>
+            <a:spLocks noGrp="1"/>
+          </p:cNvSpPr>
+          <p:nvPr/>
+        </p:nvSpPr>
+        <p:spPr>
+          <a:xfrm>
+            <a:off x="621792" y="5577840"/>
+            <a:ext cx="10607040" cy="777240"/>
+          </a:xfrm>
+          <a:prstGeom prst="rect">
+            <a:avLst/>
+          </a:prstGeom>
+          <a:noFill/>
+          <a:ln w="0">
+            <a:noFill/>
+          </a:ln>
+        </p:spPr>
+        <p:txBody>
+          <a:bodyPr lIns="0" tIns="0" rIns="0" bIns="0" anchor="t">
+            <a:noAutofit/>
+          </a:bodyPr>
+          <a:lstStyle/>
+          <a:p>
+            <a:pPr algn="l" marL="246888" indent="-246888">
+              <a:spcAft>
+                <a:spcPts val="630"/>
+              </a:spcAft>
+              <a:buFont typeface="Arial"/>
+              <a:buChar char="•"/>
+              <a:defRPr sz="1400" b="0">
+                <a:solidFill>
+                  <a:srgbClr val="163047"/>
+                </a:solidFill>
+                <a:latin typeface="Arial"/>
+                <a:ea typeface="Arial"/>
+                <a:cs typeface="Arial"/>
+              </a:defRPr>
+            </a:pPr>
+            <a:r>
+              <a:rPr sz="1400" b="0">
+                <a:solidFill>
+                  <a:srgbClr val="163047"/>
+                </a:solidFill>
+                <a:latin typeface="Arial"/>
+                <a:ea typeface="Arial"/>
+                <a:cs typeface="Arial"/>
+              </a:rPr>
+              <a:t>Đo thưa: bộ lọc thấp hơn không đo ở 46/48 và thấp hơn giữ nguyên ở 48/48 trường hợp bộ × mức nhãn × lịch đo. Biết mọi lần xả trước: giữ nguyên thấp nhất ở 23/25 trường hợp</a:t>
+            </a:r>
+          </a:p>
+        </p:txBody>
+      </p:sp>
+    </p:spTree>
+  </p:cSld>
+  <p:clrMapOvr>
+    <a:masterClrMapping/>
+  </p:clrMapOvr>
+</p:sld>
+</file>
+
+<file path=ppt/slides/slide36.xml><?xml version="1.0" encoding="utf-8"?>
+<p:sld xmlns:a="http://schemas.openxmlformats.org/drawingml/2006/main" xmlns:p="http://schemas.openxmlformats.org/presentationml/2006/main" xmlns:r="http://schemas.openxmlformats.org/officeDocument/2006/relationships">
+  <p:cSld>
+    <p:bg>
+      <p:bgPr>
+        <a:solidFill>
+          <a:srgbClr val="FFFFFF"/>
+        </a:solidFill>
+      </p:bgPr>
+    </p:bg>
+    <p:spTree>
+      <p:nvGrpSpPr>
+        <p:cNvPr id="1" name=""/>
+        <p:cNvGrpSpPr/>
+        <p:nvPr/>
+      </p:nvGrpSpPr>
+      <p:grpSpPr/>
+      <p:sp>
+        <p:nvSpPr>
+          <p:cNvPr id="12" name="">
+            <a:extLst>
+              <a:ext uri="{FF2B5EF4-FFF2-40B4-BE49-F238E27FC236}">
+                <a16:creationId xmlns:a16="http://schemas.microsoft.com/office/drawing/2014/main" id="{37D1E096-D5FA-4F41-AEBA-B2142831C0DF}"/>
+              </a:ext>
+            </a:extLst>
+          </p:cNvPr>
+          <p:cNvSpPr>
+            <a:spLocks noGrp="1"/>
+          </p:cNvSpPr>
+          <p:nvPr/>
+        </p:nvSpPr>
+        <p:spPr>
+          <a:xfrm>
+            <a:off x="0" y="0"/>
+            <a:ext cx="12192000" cy="952500"/>
+          </a:xfrm>
+          <a:prstGeom prst="rect">
+            <a:avLst/>
+          </a:prstGeom>
+          <a:solidFill>
+            <a:srgbClr val="20567B"/>
+          </a:solidFill>
+          <a:ln w="9525">
+            <a:solidFill>
+              <a:srgbClr val="20567B"/>
+            </a:solidFill>
+          </a:ln>
+        </p:spPr>
+        <p:txBody>
+          <a:bodyPr/>
+          <a:p/>
+        </p:txBody>
+      </p:sp>
+      <p:sp>
+        <p:nvSpPr>
+          <p:cNvPr id="2" name="">
+            <a:extLst>
+              <a:ext uri="{FF2B5EF4-FFF2-40B4-BE49-F238E27FC236}">
+                <a16:creationId xmlns:a16="http://schemas.microsoft.com/office/drawing/2014/main" id="{AB777859-78CD-4F6A-A9B4-9F54A352F3B1}"/>
+              </a:ext>
+            </a:extLst>
+          </p:cNvPr>
+          <p:cNvSpPr>
+            <a:spLocks noGrp="1"/>
+          </p:cNvSpPr>
+          <p:nvPr/>
+        </p:nvSpPr>
+        <p:spPr>
+          <a:xfrm>
+            <a:off x="542925" y="66675"/>
+            <a:ext cx="11239500" cy="800100"/>
+          </a:xfrm>
+          <a:prstGeom prst="rect">
+            <a:avLst/>
+          </a:prstGeom>
+          <a:noFill/>
+          <a:ln w="0">
+            <a:noFill/>
+          </a:ln>
+        </p:spPr>
+        <p:txBody>
+          <a:bodyPr lIns="0" tIns="0" rIns="0" bIns="0" anchor="ctr">
+            <a:noAutofit/>
+          </a:bodyPr>
+          <a:lstStyle/>
+          <a:p>
+            <a:pPr algn="l">
+              <a:defRPr sz="2700" b="1">
+                <a:solidFill>
+                  <a:srgbClr val="FFFFFF"/>
+                </a:solidFill>
+                <a:latin typeface="Arial"/>
+                <a:ea typeface="Arial"/>
+                <a:cs typeface="Arial"/>
+              </a:defRPr>
+            </a:pPr>
+            <a:r>
+              <a:rPr sz="2700" b="1">
+                <a:solidFill>
+                  <a:srgbClr val="FFFFFF"/>
+                </a:solidFill>
+                <a:latin typeface="Arial"/>
+                <a:ea typeface="Arial"/>
+                <a:cs typeface="Arial"/>
+              </a:rPr>
+              <a:t>Ngân sách đo dung lượng</a:t>
+            </a:r>
+          </a:p>
+        </p:txBody>
+      </p:sp>
+      <p:sp>
+        <p:nvSpPr>
+          <p:cNvPr id="3" name="">
+            <a:extLst>
+              <a:ext uri="{FF2B5EF4-FFF2-40B4-BE49-F238E27FC236}">
+                <a16:creationId xmlns:a16="http://schemas.microsoft.com/office/drawing/2014/main" id="{423E2091-FE09-4D1F-980D-5BDE30F015D5}"/>
+              </a:ext>
+            </a:extLst>
+          </p:cNvPr>
+          <p:cNvSpPr>
+            <a:spLocks noGrp="1"/>
+          </p:cNvSpPr>
+          <p:nvPr/>
+        </p:nvSpPr>
+        <p:spPr>
+          <a:xfrm>
+            <a:off x="11144250" y="6400800"/>
+            <a:ext cx="333375" cy="257175"/>
+          </a:xfrm>
+          <a:prstGeom prst="rect">
+            <a:avLst/>
+          </a:prstGeom>
+          <a:noFill/>
+          <a:ln w="0">
+            <a:noFill/>
+          </a:ln>
+        </p:spPr>
+        <p:txBody>
+          <a:bodyPr lIns="0" tIns="0" rIns="0" bIns="0" anchor="ctr">
+            <a:noAutofit/>
+          </a:bodyPr>
+          <a:lstStyle/>
+          <a:p>
+            <a:pPr algn="l">
+              <a:defRPr sz="1200" b="1">
+                <a:solidFill>
+                  <a:srgbClr val="20567B"/>
+                </a:solidFill>
+                <a:latin typeface="Arial"/>
+                <a:ea typeface="Arial"/>
+                <a:cs typeface="Arial"/>
+              </a:defRPr>
+            </a:pPr>
+            <a:r>
+              <a:rPr sz="1200" b="1">
+                <a:solidFill>
+                  <a:srgbClr val="20567B"/>
+                </a:solidFill>
+                <a:latin typeface="Arial"/>
+                <a:ea typeface="Arial"/>
+                <a:cs typeface="Arial"/>
+              </a:rPr>
+              <a:t>21</a:t>
+            </a:r>
+          </a:p>
+        </p:txBody>
+      </p:sp>
+      <p:pic>
+        <p:nvPicPr>
+          <p:cNvPr id="15" name=""/>
+          <p:cNvPicPr>
+            <a:picLocks noChangeAspect="1"/>
+          </p:cNvPicPr>
+          <p:nvPr/>
+        </p:nvPicPr>
+        <p:blipFill>
+          <a:blip r:embed="rId2"/>
+          <a:stretch/>
+        </p:blipFill>
+        <p:spPr>
+          <a:xfrm>
+            <a:off x="11696700" y="6384974"/>
+            <a:ext cx="285750" cy="260252"/>
+          </a:xfrm>
+          <a:prstGeom prst="rect">
+            <a:avLst/>
+          </a:prstGeom>
+        </p:spPr>
+      </p:pic>
+      <p:sp>
+        <p:nvSpPr>
+          <p:cNvPr id="5" name="">
+            <a:extLst>
+              <a:ext uri="{FF2B5EF4-FFF2-40B4-BE49-F238E27FC236}">
+                <a16:creationId xmlns:a16="http://schemas.microsoft.com/office/drawing/2014/main" id="{61ADA485-A3D9-4801-AF20-EEDA600A294B}"/>
+              </a:ext>
+            </a:extLst>
+          </p:cNvPr>
+          <p:cNvSpPr>
+            <a:spLocks noGrp="1"/>
+          </p:cNvSpPr>
+          <p:nvPr/>
+        </p:nvSpPr>
+        <p:spPr>
+          <a:xfrm>
+            <a:off x="521207" y="1143000"/>
+            <a:ext cx="6949440" cy="5074920"/>
+          </a:xfrm>
+          <a:prstGeom prst="rect">
+            <a:avLst/>
+          </a:prstGeom>
+          <a:solidFill>
+            <a:srgbClr val="FFFFFF"/>
+          </a:solidFill>
+          <a:ln w="9525">
+            <a:solidFill>
+              <a:srgbClr val="A7BAC7"/>
+            </a:solidFill>
+          </a:ln>
+        </p:spPr>
+        <p:txBody>
+          <a:bodyPr/>
+          <a:p/>
+        </p:txBody>
+      </p:sp>
+      <p:pic>
+        <p:nvPicPr>
+          <p:cNvPr id="16" name="Picture 15" descr="fig_e28_budget.png"/>
+          <p:cNvPicPr>
+            <a:picLocks noChangeAspect="1"/>
+          </p:cNvPicPr>
+          <p:nvPr/>
+        </p:nvPicPr>
+        <p:blipFill>
+          <a:blip r:embed="rId3"/>
+          <a:stretch>
+            <a:fillRect/>
+          </a:stretch>
+        </p:blipFill>
+        <p:spPr>
+          <a:xfrm>
+            <a:off x="630936" y="1261388"/>
+            <a:ext cx="6729982" cy="4838144"/>
+          </a:xfrm>
+          <a:prstGeom prst="rect">
+            <a:avLst/>
+          </a:prstGeom>
+        </p:spPr>
+      </p:pic>
+      <p:sp>
+        <p:nvSpPr>
+          <p:cNvPr id="5" name="">
+            <a:extLst>
+              <a:ext uri="{FF2B5EF4-FFF2-40B4-BE49-F238E27FC236}">
+                <a16:creationId xmlns:a16="http://schemas.microsoft.com/office/drawing/2014/main" id="{C1E2F7BC-C449-49C6-B60D-A5759C565738}"/>
+              </a:ext>
+            </a:extLst>
+          </p:cNvPr>
+          <p:cNvSpPr>
+            <a:spLocks noGrp="1"/>
+          </p:cNvSpPr>
+          <p:nvPr/>
+        </p:nvSpPr>
+        <p:spPr>
+          <a:xfrm>
+            <a:off x="7726679" y="1325880"/>
+            <a:ext cx="3931920" cy="329184"/>
+          </a:xfrm>
+          <a:prstGeom prst="rect">
+            <a:avLst/>
+          </a:prstGeom>
+          <a:noFill/>
+          <a:ln w="0">
+            <a:noFill/>
+          </a:ln>
+        </p:spPr>
+        <p:txBody>
+          <a:bodyPr lIns="0" tIns="0" rIns="0" bIns="0" anchor="ctr">
+            <a:noAutofit/>
+          </a:bodyPr>
+          <a:lstStyle/>
+          <a:p>
+            <a:pPr algn="l">
+              <a:defRPr sz="1700" b="1">
+                <a:solidFill>
+                  <a:srgbClr val="20567B"/>
+                </a:solidFill>
+                <a:latin typeface="Arial"/>
+                <a:ea typeface="Arial"/>
+                <a:cs typeface="Arial"/>
+              </a:defRPr>
+            </a:pPr>
+            <a:r>
+              <a:rPr sz="1700" b="1">
+                <a:solidFill>
+                  <a:srgbClr val="20567B"/>
+                </a:solidFill>
+                <a:latin typeface="Arial"/>
+                <a:ea typeface="Arial"/>
+                <a:cs typeface="Arial"/>
+              </a:rPr>
+              <a:t>Đo thưa mọi cell</a:t>
+            </a:r>
+          </a:p>
+        </p:txBody>
+      </p:sp>
+      <p:sp>
+        <p:nvSpPr>
+          <p:cNvPr id="6" name="">
+            <a:extLst>
+              <a:ext uri="{FF2B5EF4-FFF2-40B4-BE49-F238E27FC236}">
+                <a16:creationId xmlns:a16="http://schemas.microsoft.com/office/drawing/2014/main" id="{EE2ABE15-3EEB-4EA0-9CA6-5CA037A62878}"/>
+              </a:ext>
+            </a:extLst>
+          </p:cNvPr>
+          <p:cNvSpPr>
+            <a:spLocks noGrp="1"/>
+          </p:cNvSpPr>
+          <p:nvPr/>
+        </p:nvSpPr>
+        <p:spPr>
+          <a:xfrm>
+            <a:off x="7726679" y="1709928"/>
+            <a:ext cx="3931920" cy="1025652"/>
+          </a:xfrm>
+          <a:prstGeom prst="rect">
+            <a:avLst/>
+          </a:prstGeom>
+          <a:noFill/>
+          <a:ln w="0">
+            <a:noFill/>
+          </a:ln>
+        </p:spPr>
+        <p:txBody>
+          <a:bodyPr lIns="0" tIns="0" rIns="0" bIns="0" anchor="t">
+            <a:noAutofit/>
+          </a:bodyPr>
+          <a:lstStyle/>
+          <a:p>
+            <a:pPr algn="l">
+              <a:spcAft>
+                <a:spcPts val="675"/>
+              </a:spcAft>
+              <a:defRPr sz="1500" b="0">
+                <a:solidFill>
+                  <a:srgbClr val="163047"/>
+                </a:solidFill>
+                <a:latin typeface="Arial"/>
+                <a:ea typeface="Arial"/>
+                <a:cs typeface="Arial"/>
+              </a:defRPr>
+            </a:pPr>
+            <a:r>
+              <a:rPr sz="1500" b="0">
+                <a:solidFill>
+                  <a:srgbClr val="163047"/>
+                </a:solidFill>
+                <a:latin typeface="Arial"/>
+                <a:ea typeface="Arial"/>
+                <a:cs typeface="Arial"/>
+              </a:rPr>
+              <a:t>Chỉ đo 1,2–6,0 % số chu kỳ, PINN-lai có sai số bằng 0,85–0,93 lần gắn nhãn đầy đủ cho 30 % số cell và 0,97–1,05 lần khi gắn cho 70 %.</a:t>
+            </a:r>
+          </a:p>
+        </p:txBody>
+      </p:sp>
+      <p:sp>
+        <p:nvSpPr>
+          <p:cNvPr id="5" name="">
+            <a:extLst>
+              <a:ext uri="{FF2B5EF4-FFF2-40B4-BE49-F238E27FC236}">
+                <a16:creationId xmlns:a16="http://schemas.microsoft.com/office/drawing/2014/main" id="{C1E2F7BC-C449-49C6-B60D-A5759C565738}"/>
+              </a:ext>
+            </a:extLst>
+          </p:cNvPr>
+          <p:cNvSpPr>
+            <a:spLocks noGrp="1"/>
+          </p:cNvSpPr>
+          <p:nvPr/>
+        </p:nvSpPr>
+        <p:spPr>
+          <a:xfrm>
+            <a:off x="7726679" y="2845307"/>
+            <a:ext cx="3931920" cy="329184"/>
+          </a:xfrm>
+          <a:prstGeom prst="rect">
+            <a:avLst/>
+          </a:prstGeom>
+          <a:noFill/>
+          <a:ln w="0">
+            <a:noFill/>
+          </a:ln>
+        </p:spPr>
+        <p:txBody>
+          <a:bodyPr lIns="0" tIns="0" rIns="0" bIns="0" anchor="ctr">
+            <a:noAutofit/>
+          </a:bodyPr>
+          <a:lstStyle/>
+          <a:p>
+            <a:pPr algn="l">
+              <a:defRPr sz="1700" b="1">
+                <a:solidFill>
+                  <a:srgbClr val="20567B"/>
+                </a:solidFill>
+                <a:latin typeface="Arial"/>
+                <a:ea typeface="Arial"/>
+                <a:cs typeface="Arial"/>
+              </a:defRPr>
+            </a:pPr>
+            <a:r>
+              <a:rPr sz="1700" b="1">
+                <a:solidFill>
+                  <a:srgbClr val="20567B"/>
+                </a:solidFill>
+                <a:latin typeface="Arial"/>
+                <a:ea typeface="Arial"/>
+                <a:cs typeface="Arial"/>
+              </a:rPr>
+              <a:t>Đo cả cell mới</a:t>
+            </a:r>
+          </a:p>
+        </p:txBody>
+      </p:sp>
+      <p:sp>
+        <p:nvSpPr>
+          <p:cNvPr id="6" name="">
+            <a:extLst>
+              <a:ext uri="{FF2B5EF4-FFF2-40B4-BE49-F238E27FC236}">
+                <a16:creationId xmlns:a16="http://schemas.microsoft.com/office/drawing/2014/main" id="{EE2ABE15-3EEB-4EA0-9CA6-5CA037A62878}"/>
+              </a:ext>
+            </a:extLst>
+          </p:cNvPr>
+          <p:cNvSpPr>
+            <a:spLocks noGrp="1"/>
+          </p:cNvSpPr>
+          <p:nvPr/>
+        </p:nvSpPr>
+        <p:spPr>
+          <a:xfrm>
+            <a:off x="7726679" y="3229355"/>
+            <a:ext cx="3931920" cy="787527"/>
+          </a:xfrm>
+          <a:prstGeom prst="rect">
+            <a:avLst/>
+          </a:prstGeom>
+          <a:noFill/>
+          <a:ln w="0">
+            <a:noFill/>
+          </a:ln>
+        </p:spPr>
+        <p:txBody>
+          <a:bodyPr lIns="0" tIns="0" rIns="0" bIns="0" anchor="t">
+            <a:noAutofit/>
+          </a:bodyPr>
+          <a:lstStyle/>
+          <a:p>
+            <a:pPr algn="l">
+              <a:spcAft>
+                <a:spcPts val="675"/>
+              </a:spcAft>
+              <a:defRPr sz="1500" b="0">
+                <a:solidFill>
+                  <a:srgbClr val="163047"/>
+                </a:solidFill>
+                <a:latin typeface="Arial"/>
+                <a:ea typeface="Arial"/>
+                <a:cs typeface="Arial"/>
+              </a:defRPr>
+            </a:pPr>
+            <a:r>
+              <a:rPr sz="1500" b="0">
+                <a:solidFill>
+                  <a:srgbClr val="163047"/>
+                </a:solidFill>
+                <a:latin typeface="Arial"/>
+                <a:ea typeface="Arial"/>
+                <a:cs typeface="Arial"/>
+              </a:rPr>
+              <a:t>Cập nhật bằng bộ lọc Kalman, sai số còn 0,34–0,77 lần GBDT học với 70 % cell có nhãn.</a:t>
+            </a:r>
+          </a:p>
+        </p:txBody>
+      </p:sp>
+    </p:spTree>
+  </p:cSld>
+  <p:clrMapOvr>
+    <a:masterClrMapping/>
+  </p:clrMapOvr>
+</p:sld>
+</file>
+
+<file path=ppt/slides/slide37.xml><?xml version="1.0" encoding="utf-8"?>
+<p:sld xmlns:a="http://schemas.openxmlformats.org/drawingml/2006/main" xmlns:p="http://schemas.openxmlformats.org/presentationml/2006/main" xmlns:r="http://schemas.openxmlformats.org/officeDocument/2006/relationships">
+  <p:cSld>
+    <p:bg>
+      <p:bgPr>
+        <a:solidFill>
+          <a:srgbClr val="FFFFFF"/>
+        </a:solidFill>
+      </p:bgPr>
+    </p:bg>
+    <p:spTree>
+      <p:nvGrpSpPr>
+        <p:cNvPr id="1" name=""/>
+        <p:cNvGrpSpPr/>
+        <p:nvPr/>
+      </p:nvGrpSpPr>
+      <p:grpSpPr/>
+      <p:sp>
+        <p:nvSpPr>
+          <p:cNvPr id="12" name="">
+            <a:extLst>
+              <a:ext uri="{FF2B5EF4-FFF2-40B4-BE49-F238E27FC236}">
+                <a16:creationId xmlns:a16="http://schemas.microsoft.com/office/drawing/2014/main" id="{37D1E096-D5FA-4F41-AEBA-B2142831C0DF}"/>
+              </a:ext>
+            </a:extLst>
+          </p:cNvPr>
+          <p:cNvSpPr>
+            <a:spLocks noGrp="1"/>
+          </p:cNvSpPr>
+          <p:nvPr/>
+        </p:nvSpPr>
+        <p:spPr>
+          <a:xfrm>
+            <a:off x="0" y="0"/>
+            <a:ext cx="12192000" cy="952500"/>
+          </a:xfrm>
+          <a:prstGeom prst="rect">
+            <a:avLst/>
+          </a:prstGeom>
+          <a:solidFill>
+            <a:srgbClr val="20567B"/>
+          </a:solidFill>
+          <a:ln w="9525">
+            <a:solidFill>
+              <a:srgbClr val="20567B"/>
+            </a:solidFill>
+          </a:ln>
+        </p:spPr>
+        <p:txBody>
+          <a:bodyPr/>
+          <a:p/>
+        </p:txBody>
+      </p:sp>
+      <p:sp>
+        <p:nvSpPr>
+          <p:cNvPr id="2" name="">
+            <a:extLst>
+              <a:ext uri="{FF2B5EF4-FFF2-40B4-BE49-F238E27FC236}">
+                <a16:creationId xmlns:a16="http://schemas.microsoft.com/office/drawing/2014/main" id="{AB777859-78CD-4F6A-A9B4-9F54A352F3B1}"/>
+              </a:ext>
+            </a:extLst>
+          </p:cNvPr>
+          <p:cNvSpPr>
+            <a:spLocks noGrp="1"/>
+          </p:cNvSpPr>
+          <p:nvPr/>
+        </p:nvSpPr>
+        <p:spPr>
+          <a:xfrm>
+            <a:off x="542925" y="66675"/>
+            <a:ext cx="11239500" cy="800100"/>
+          </a:xfrm>
+          <a:prstGeom prst="rect">
+            <a:avLst/>
+          </a:prstGeom>
+          <a:noFill/>
+          <a:ln w="0">
+            <a:noFill/>
+          </a:ln>
+        </p:spPr>
+        <p:txBody>
+          <a:bodyPr lIns="0" tIns="0" rIns="0" bIns="0" anchor="ctr">
+            <a:noAutofit/>
+          </a:bodyPr>
+          <a:lstStyle/>
+          <a:p>
+            <a:pPr algn="l">
+              <a:defRPr sz="2700" b="1">
+                <a:solidFill>
+                  <a:srgbClr val="FFFFFF"/>
+                </a:solidFill>
+                <a:latin typeface="Arial"/>
+                <a:ea typeface="Arial"/>
+                <a:cs typeface="Arial"/>
+              </a:defRPr>
+            </a:pPr>
+            <a:r>
+              <a:rPr sz="2700" b="1">
+                <a:solidFill>
+                  <a:srgbClr val="FFFFFF"/>
+                </a:solidFill>
+                <a:latin typeface="Arial"/>
+                <a:ea typeface="Arial"/>
+                <a:cs typeface="Arial"/>
+              </a:rPr>
+              <a:t>Đối chiếu với đề cương (giai đoạn 1)</a:t>
+            </a:r>
+          </a:p>
+        </p:txBody>
+      </p:sp>
+      <p:sp>
+        <p:nvSpPr>
+          <p:cNvPr id="3" name="">
+            <a:extLst>
+              <a:ext uri="{FF2B5EF4-FFF2-40B4-BE49-F238E27FC236}">
+                <a16:creationId xmlns:a16="http://schemas.microsoft.com/office/drawing/2014/main" id="{423E2091-FE09-4D1F-980D-5BDE30F015D5}"/>
+              </a:ext>
+            </a:extLst>
+          </p:cNvPr>
+          <p:cNvSpPr>
+            <a:spLocks noGrp="1"/>
+          </p:cNvSpPr>
+          <p:nvPr/>
+        </p:nvSpPr>
+        <p:spPr>
+          <a:xfrm>
+            <a:off x="11144250" y="6400800"/>
+            <a:ext cx="333375" cy="257175"/>
+          </a:xfrm>
+          <a:prstGeom prst="rect">
+            <a:avLst/>
+          </a:prstGeom>
+          <a:noFill/>
+          <a:ln w="0">
+            <a:noFill/>
+          </a:ln>
+        </p:spPr>
+        <p:txBody>
+          <a:bodyPr lIns="0" tIns="0" rIns="0" bIns="0" anchor="ctr">
+            <a:noAutofit/>
+          </a:bodyPr>
+          <a:lstStyle/>
+          <a:p>
+            <a:pPr algn="l">
+              <a:defRPr sz="1200" b="1">
+                <a:solidFill>
+                  <a:srgbClr val="20567B"/>
+                </a:solidFill>
+                <a:latin typeface="Arial"/>
+                <a:ea typeface="Arial"/>
+                <a:cs typeface="Arial"/>
+              </a:defRPr>
+            </a:pPr>
+            <a:r>
+              <a:rPr sz="1200" b="1">
+                <a:solidFill>
+                  <a:srgbClr val="20567B"/>
+                </a:solidFill>
+                <a:latin typeface="Arial"/>
+                <a:ea typeface="Arial"/>
+                <a:cs typeface="Arial"/>
+              </a:rPr>
+              <a:t>22</a:t>
             </a:r>
           </a:p>
         </p:txBody>
@@ -15503,7 +17241,7 @@
                           <a:ea typeface="Arial"/>
                           <a:cs typeface="Arial"/>
                         </a:rPr>
-                        <a:t>Độ dài cửa sổ; trọng số ghép, cửa sổ lọc; dạng lịch sử; bộ lọc đơn điệu</a:t>
+                        <a:t>Độ dài cửa sổ; trọng số ghép, cửa sổ lọc; dạng lịch sử; đặc trưng cả lần sạc NASA</a:t>
                       </a:r>
                     </a:p>
                   </a:txBody>
@@ -15682,7 +17420,7 @@
 </p:sld>
 </file>
 
-<file path=ppt/slides/slide36.xml><?xml version="1.0" encoding="utf-8"?>
+<file path=ppt/slides/slide38.xml><?xml version="1.0" encoding="utf-8"?>
 <p:sld xmlns:a="http://schemas.openxmlformats.org/drawingml/2006/main" xmlns:p="http://schemas.openxmlformats.org/presentationml/2006/main" xmlns:r="http://schemas.openxmlformats.org/officeDocument/2006/relationships">
   <p:cSld>
     <p:bg>
@@ -15844,7 +17582,7 @@
                 <a:ea typeface="Arial"/>
                 <a:cs typeface="Arial"/>
               </a:rPr>
-              <a:t>21</a:t>
+              <a:t>23</a:t>
             </a:r>
           </a:p>
         </p:txBody>
@@ -16072,6 +17810,34 @@
               <a:t>Rải vài lần đo lên mọi cell hiệu quả hơn đo kín một phần cell</a:t>
             </a:r>
           </a:p>
+          <a:p>
+            <a:pPr algn="l" marL="246888" indent="-246888">
+              <a:spcAft>
+                <a:spcPts val="720"/>
+              </a:spcAft>
+              <a:buFont typeface="Arial"/>
+              <a:buChar char="•"/>
+              <a:defRPr sz="1600" b="0">
+                <a:solidFill>
+                  <a:srgbClr val="163047"/>
+                </a:solidFill>
+                <a:latin typeface="Arial"/>
+                <a:ea typeface="Arial"/>
+                <a:cs typeface="Arial"/>
+              </a:defRPr>
+            </a:pPr>
+            <a:r>
+              <a:rPr sz="1600" b="0">
+                <a:solidFill>
+                  <a:srgbClr val="163047"/>
+                </a:solidFill>
+                <a:latin typeface="Arial"/>
+                <a:ea typeface="Arial"/>
+                <a:cs typeface="Arial"/>
+              </a:rPr>
+              <a:t>NASA-L: chỉ thấp hơn SambaMixer khi biết mọi lần xả trước (0,80 %; giữ nguyên: 0,60 %)</a:t>
+            </a:r>
+          </a:p>
         </p:txBody>
       </p:sp>
       <p:sp>
@@ -16285,7 +18051,7 @@
 </p:sld>
 </file>
 
-<file path=ppt/slides/slide37.xml><?xml version="1.0" encoding="utf-8"?>
+<file path=ppt/slides/slide39.xml><?xml version="1.0" encoding="utf-8"?>
 <p:sld xmlns:a="http://schemas.openxmlformats.org/drawingml/2006/main" xmlns:p="http://schemas.openxmlformats.org/presentationml/2006/main" xmlns:r="http://schemas.openxmlformats.org/officeDocument/2006/relationships">
   <p:cSld>
     <p:spTree>

</xml_diff>

<commit_message>
E32: kết quả mô hình học cập nhật trên mọi bộ; báo cáo 75 trang, README, slide
Trên NASA-L (24 cột), đo thêm cell 8 lần cho MAE 0,63 %, mỗi 0,1L 0,40 % (thấp hơn SambaMixer
0,96 % trên cả ba cell), so với 1,89 và 1,58 % của bộ lọc Kalman. Kiểm định chéo 18 cell NASA: thấp
hơn giữ nguyên có ý nghĩa ở 5/6 trường hợp đo thưa. Bốn bộ chính: khi đo thưa thấp hơn bộ lọc ở
47/48 và giữ nguyên ở 48/48 trường hợp; khi biết mọi lần xả trước, thấp hơn giữ nguyên ở 12/16.
306 lượt, không lượt nào lỗi.

Co-Authored-By: Claude Opus 5.5 <noreply@anthropic.com>
Claude-Session: https://claude.ai/code/session_01WsTkwYUpiJBnAt7LHynU5S
</commit_message>
<xml_diff>
--- a/pinn-soh/slide/Thuyet_trinh_DACN_Nhom15.pptx
+++ b/pinn-soh/slide/Thuyet_trinh_DACN_Nhom15.pptx
@@ -1520,7 +1520,7 @@
           <a:lstStyle/>
           <a:p>
             <a:r>
-              <a:t>SambaMixer nhận đường xả của chính chu kỳ cần ước lượng, nên nhãn gần như nằm trong đầu vào. Em tách ba mức thông tin về chính cell: không đo, đo thưa, và biết mọi lần xả trước. Đồ án chỉ thấp hơn SambaMixer khi có thêm các lần đo của chính cell; ở mức cao nhất, cách giữ nguyên lần đo trước không cần mô hình cũng thấp hơn, nên phần thắng đến từ thông tin chứ không từ mô hình. Biến thể κ được đặt ra sau khi xem kết quả trên các bộ khác, em ghi rõ là hậu kiểm.</a:t>
+              <a:t>SambaMixer nhận đường xả của chính chu kỳ cần ước lượng, nên nhãn gần như nằm trong đầu vào. Em tách ba mức thông tin về chính cell: không đo, đo thưa, và biết mọi lần xả trước. Không đo cell thì đồ án vẫn kém. Khi đo thêm vài lần, mô hình cập nhật học thẳng dung lượng đã đổi bao nhiêu kể từ lần đo gần nhất, từ thay đổi của đặc trưng sạc; với tám lần đo trong đời cell nó đã thấp hơn SambaMixer. Thiết kế của mô hình này chốt trước khi chạy, chọn chỉ trên các cell không thuộc tập đánh giá.</a:t>
             </a:r>
           </a:p>
         </p:txBody>
@@ -1590,7 +1590,7 @@
           <a:lstStyle/>
           <a:p>
             <a:r>
-              <a:t>Cùng các mức đo trên bốn bộ chính và trên kiểm định chéo của NASA. Giữa hai lần đo thưa, mô hình biết dung lượng giảm bao nhiêu nên tốt hơn hẳn giữ nguyên; khi đã đo mọi chu kỳ trước, thay đổi mô hình dự đoán giữa hai chu kỳ liền nhau nhiễu hơn thay đổi thật, nên giữ nguyên thắng. Giá trị của mô hình nằm ở chỗ đo thưa.</a:t>
+              <a:t>Cùng các mức đo trên bốn bộ chính và trên kiểm định chéo của NASA. Đường tím là mô hình cập nhật, thấp nhất ở mọi ô. Bộ lọc Kalman chỉ sửa độ lệch của mô hình không đo, nên khi đã đo mọi chu kỳ trước nó còn kém cách giữ nguyên; mô hình cập nhật học thẳng thay đổi kể từ lần đo nên thắng cả hai.</a:t>
             </a:r>
           </a:p>
         </p:txBody>
@@ -7347,7 +7347,7 @@
                 <a:ea typeface="Arial"/>
                 <a:cs typeface="Arial"/>
               </a:rPr>
-              <a:t>Python, PyTorch, scikit-learn; một lệnh chạy từ dữ liệu thô tới báo cáo; 10.720 lượt huấn luyện được trình bày</a:t>
+              <a:t>Python, PyTorch, scikit-learn; một lệnh chạy từ dữ liệu thô tới báo cáo; 11.026 lượt huấn luyện được trình bày</a:t>
             </a:r>
           </a:p>
           <a:p>
@@ -14895,7 +14895,7 @@
         </p:nvGraphicFramePr>
         <p:xfrm>
           <a:off x="530352" y="1280160"/>
-          <a:ext cx="6949440" cy="2514600"/>
+          <a:ext cx="6949440" cy="2852928"/>
         </p:xfrm>
         <a:graphic>
           <a:graphicData uri="http://schemas.openxmlformats.org/drawingml/2006/table">
@@ -14909,7 +14909,7 @@
                 <a:gridCol w="868680"/>
                 <a:gridCol w="1143000"/>
               </a:tblGrid>
-              <a:tr h="502920">
+              <a:tr h="475488">
                 <a:tc>
                   <a:txBody>
                     <a:bodyPr/>
@@ -15061,7 +15061,7 @@
                   </a:tcPr>
                 </a:tc>
               </a:tr>
-              <a:tr h="502920">
+              <a:tr h="475488">
                 <a:tc>
                   <a:txBody>
                     <a:bodyPr/>
@@ -15213,7 +15213,7 @@
                   </a:tcPr>
                 </a:tc>
               </a:tr>
-              <a:tr h="502920">
+              <a:tr h="475488">
                 <a:tc>
                   <a:txBody>
                     <a:bodyPr/>
@@ -15365,7 +15365,159 @@
                   </a:tcPr>
                 </a:tc>
               </a:tr>
-              <a:tr h="502920">
+              <a:tr h="475488">
+                <a:tc>
+                  <a:txBody>
+                    <a:bodyPr/>
+                    <a:lstStyle/>
+                    <a:p>
+                      <a:pPr algn="l"/>
+                      <a:r>
+                        <a:rPr sz="1300" b="0">
+                          <a:solidFill>
+                            <a:srgbClr val="163047"/>
+                          </a:solidFill>
+                          <a:latin typeface="Arial"/>
+                          <a:ea typeface="Arial"/>
+                          <a:cs typeface="Arial"/>
+                        </a:rPr>
+                        <a:t>Mô hình cập nhật</a:t>
+                      </a:r>
+                    </a:p>
+                  </a:txBody>
+                  <a:tcPr marL="91440" marR="91440" marT="45720" marB="45720" anchor="ctr">
+                    <a:solidFill>
+                      <a:srgbClr val="EAF3F7"/>
+                    </a:solidFill>
+                  </a:tcPr>
+                </a:tc>
+                <a:tc>
+                  <a:txBody>
+                    <a:bodyPr/>
+                    <a:lstStyle/>
+                    <a:p>
+                      <a:pPr algn="l"/>
+                      <a:r>
+                        <a:rPr sz="1300" b="0">
+                          <a:solidFill>
+                            <a:srgbClr val="163047"/>
+                          </a:solidFill>
+                          <a:latin typeface="Arial"/>
+                          <a:ea typeface="Arial"/>
+                          <a:cs typeface="Arial"/>
+                        </a:rPr>
+                        <a:t>–</a:t>
+                      </a:r>
+                    </a:p>
+                  </a:txBody>
+                  <a:tcPr marL="91440" marR="91440" marT="45720" marB="45720" anchor="ctr">
+                    <a:solidFill>
+                      <a:srgbClr val="EAF3F7"/>
+                    </a:solidFill>
+                  </a:tcPr>
+                </a:tc>
+                <a:tc>
+                  <a:txBody>
+                    <a:bodyPr/>
+                    <a:lstStyle/>
+                    <a:p>
+                      <a:pPr algn="l"/>
+                      <a:r>
+                        <a:rPr sz="1300" b="1">
+                          <a:solidFill>
+                            <a:srgbClr val="0D6E56"/>
+                          </a:solidFill>
+                          <a:latin typeface="Arial"/>
+                          <a:ea typeface="Arial"/>
+                          <a:cs typeface="Arial"/>
+                        </a:rPr>
+                        <a:t>0,63</a:t>
+                      </a:r>
+                    </a:p>
+                  </a:txBody>
+                  <a:tcPr marL="91440" marR="91440" marT="45720" marB="45720" anchor="ctr">
+                    <a:solidFill>
+                      <a:srgbClr val="EAF3F7"/>
+                    </a:solidFill>
+                  </a:tcPr>
+                </a:tc>
+                <a:tc>
+                  <a:txBody>
+                    <a:bodyPr/>
+                    <a:lstStyle/>
+                    <a:p>
+                      <a:pPr algn="l"/>
+                      <a:r>
+                        <a:rPr sz="1300" b="1">
+                          <a:solidFill>
+                            <a:srgbClr val="0D6E56"/>
+                          </a:solidFill>
+                          <a:latin typeface="Arial"/>
+                          <a:ea typeface="Arial"/>
+                          <a:cs typeface="Arial"/>
+                        </a:rPr>
+                        <a:t>0,40</a:t>
+                      </a:r>
+                    </a:p>
+                  </a:txBody>
+                  <a:tcPr marL="91440" marR="91440" marT="45720" marB="45720" anchor="ctr">
+                    <a:solidFill>
+                      <a:srgbClr val="EAF3F7"/>
+                    </a:solidFill>
+                  </a:tcPr>
+                </a:tc>
+                <a:tc>
+                  <a:txBody>
+                    <a:bodyPr/>
+                    <a:lstStyle/>
+                    <a:p>
+                      <a:pPr algn="l"/>
+                      <a:r>
+                        <a:rPr sz="1300" b="1">
+                          <a:solidFill>
+                            <a:srgbClr val="0D6E56"/>
+                          </a:solidFill>
+                          <a:latin typeface="Arial"/>
+                          <a:ea typeface="Arial"/>
+                          <a:cs typeface="Arial"/>
+                        </a:rPr>
+                        <a:t>0,35</a:t>
+                      </a:r>
+                    </a:p>
+                  </a:txBody>
+                  <a:tcPr marL="91440" marR="91440" marT="45720" marB="45720" anchor="ctr">
+                    <a:solidFill>
+                      <a:srgbClr val="EAF3F7"/>
+                    </a:solidFill>
+                  </a:tcPr>
+                </a:tc>
+                <a:tc>
+                  <a:txBody>
+                    <a:bodyPr/>
+                    <a:lstStyle/>
+                    <a:p>
+                      <a:pPr algn="l"/>
+                      <a:r>
+                        <a:rPr sz="1300" b="1">
+                          <a:solidFill>
+                            <a:srgbClr val="0D6E56"/>
+                          </a:solidFill>
+                          <a:latin typeface="Arial"/>
+                          <a:ea typeface="Arial"/>
+                          <a:cs typeface="Arial"/>
+                        </a:rPr>
+                        <a:t>0,33</a:t>
+                      </a:r>
+                    </a:p>
+                  </a:txBody>
+                  <a:tcPr marL="91440" marR="91440" marT="45720" marB="45720" anchor="ctr">
+                    <a:solidFill>
+                      <a:srgbClr val="EAF3F7"/>
+                    </a:solidFill>
+                  </a:tcPr>
+                </a:tc>
+              </a:tr>
+              <a:tr h="475488">
                 <a:tc>
                   <a:txBody>
                     <a:bodyPr/>
@@ -15382,6 +15534,158 @@
                           <a:cs typeface="Arial"/>
                         </a:rPr>
                         <a:t>Gần nhất</a:t>
+                      </a:r>
+                    </a:p>
+                  </a:txBody>
+                  <a:tcPr marL="91440" marR="91440" marT="45720" marB="45720" anchor="ctr">
+                    <a:solidFill>
+                      <a:srgbClr val="FFFFFF"/>
+                    </a:solidFill>
+                  </a:tcPr>
+                </a:tc>
+                <a:tc>
+                  <a:txBody>
+                    <a:bodyPr/>
+                    <a:lstStyle/>
+                    <a:p>
+                      <a:pPr algn="l"/>
+                      <a:r>
+                        <a:rPr sz="1300" b="0">
+                          <a:solidFill>
+                            <a:srgbClr val="163047"/>
+                          </a:solidFill>
+                          <a:latin typeface="Arial"/>
+                          <a:ea typeface="Arial"/>
+                          <a:cs typeface="Arial"/>
+                        </a:rPr>
+                        <a:t>–</a:t>
+                      </a:r>
+                    </a:p>
+                  </a:txBody>
+                  <a:tcPr marL="91440" marR="91440" marT="45720" marB="45720" anchor="ctr">
+                    <a:solidFill>
+                      <a:srgbClr val="FFFFFF"/>
+                    </a:solidFill>
+                  </a:tcPr>
+                </a:tc>
+                <a:tc>
+                  <a:txBody>
+                    <a:bodyPr/>
+                    <a:lstStyle/>
+                    <a:p>
+                      <a:pPr algn="l"/>
+                      <a:r>
+                        <a:rPr sz="1300" b="0">
+                          <a:solidFill>
+                            <a:srgbClr val="163047"/>
+                          </a:solidFill>
+                          <a:latin typeface="Arial"/>
+                          <a:ea typeface="Arial"/>
+                          <a:cs typeface="Arial"/>
+                        </a:rPr>
+                        <a:t>2,18</a:t>
+                      </a:r>
+                    </a:p>
+                  </a:txBody>
+                  <a:tcPr marL="91440" marR="91440" marT="45720" marB="45720" anchor="ctr">
+                    <a:solidFill>
+                      <a:srgbClr val="FFFFFF"/>
+                    </a:solidFill>
+                  </a:tcPr>
+                </a:tc>
+                <a:tc>
+                  <a:txBody>
+                    <a:bodyPr/>
+                    <a:lstStyle/>
+                    <a:p>
+                      <a:pPr algn="l"/>
+                      <a:r>
+                        <a:rPr sz="1300" b="0">
+                          <a:solidFill>
+                            <a:srgbClr val="163047"/>
+                          </a:solidFill>
+                          <a:latin typeface="Arial"/>
+                          <a:ea typeface="Arial"/>
+                          <a:cs typeface="Arial"/>
+                        </a:rPr>
+                        <a:t>1,57</a:t>
+                      </a:r>
+                    </a:p>
+                  </a:txBody>
+                  <a:tcPr marL="91440" marR="91440" marT="45720" marB="45720" anchor="ctr">
+                    <a:solidFill>
+                      <a:srgbClr val="FFFFFF"/>
+                    </a:solidFill>
+                  </a:tcPr>
+                </a:tc>
+                <a:tc>
+                  <a:txBody>
+                    <a:bodyPr/>
+                    <a:lstStyle/>
+                    <a:p>
+                      <a:pPr algn="l"/>
+                      <a:r>
+                        <a:rPr sz="1300" b="0">
+                          <a:solidFill>
+                            <a:srgbClr val="163047"/>
+                          </a:solidFill>
+                          <a:latin typeface="Arial"/>
+                          <a:ea typeface="Arial"/>
+                          <a:cs typeface="Arial"/>
+                        </a:rPr>
+                        <a:t>1,19</a:t>
+                      </a:r>
+                    </a:p>
+                  </a:txBody>
+                  <a:tcPr marL="91440" marR="91440" marT="45720" marB="45720" anchor="ctr">
+                    <a:solidFill>
+                      <a:srgbClr val="FFFFFF"/>
+                    </a:solidFill>
+                  </a:tcPr>
+                </a:tc>
+                <a:tc>
+                  <a:txBody>
+                    <a:bodyPr/>
+                    <a:lstStyle/>
+                    <a:p>
+                      <a:pPr algn="l"/>
+                      <a:r>
+                        <a:rPr sz="1300" b="1">
+                          <a:solidFill>
+                            <a:srgbClr val="0D6E56"/>
+                          </a:solidFill>
+                          <a:latin typeface="Arial"/>
+                          <a:ea typeface="Arial"/>
+                          <a:cs typeface="Arial"/>
+                        </a:rPr>
+                        <a:t>0,75</a:t>
+                      </a:r>
+                    </a:p>
+                  </a:txBody>
+                  <a:tcPr marL="91440" marR="91440" marT="45720" marB="45720" anchor="ctr">
+                    <a:solidFill>
+                      <a:srgbClr val="FFFFFF"/>
+                    </a:solidFill>
+                  </a:tcPr>
+                </a:tc>
+              </a:tr>
+              <a:tr h="475488">
+                <a:tc>
+                  <a:txBody>
+                    <a:bodyPr/>
+                    <a:lstStyle/>
+                    <a:p>
+                      <a:pPr algn="l"/>
+                      <a:r>
+                        <a:rPr sz="1300" b="0">
+                          <a:solidFill>
+                            <a:srgbClr val="163047"/>
+                          </a:solidFill>
+                          <a:latin typeface="Arial"/>
+                          <a:ea typeface="Arial"/>
+                          <a:cs typeface="Arial"/>
+                        </a:rPr>
+                        <a:t>Giữ nguyên (không mô hình)</a:t>
                       </a:r>
                     </a:p>
                   </a:txBody>
@@ -15431,7 +15735,7 @@
                           <a:ea typeface="Arial"/>
                           <a:cs typeface="Arial"/>
                         </a:rPr>
-                        <a:t>2,18</a:t>
+                        <a:t>2,54</a:t>
                       </a:r>
                     </a:p>
                   </a:txBody>
@@ -15456,7 +15760,7 @@
                           <a:ea typeface="Arial"/>
                           <a:cs typeface="Arial"/>
                         </a:rPr>
-                        <a:t>1,57</a:t>
+                        <a:t>1,48</a:t>
                       </a:r>
                     </a:p>
                   </a:txBody>
@@ -15481,7 +15785,7 @@
                           <a:ea typeface="Arial"/>
                           <a:cs typeface="Arial"/>
                         </a:rPr>
-                        <a:t>1,19</a:t>
+                        <a:t>0,99</a:t>
                       </a:r>
                     </a:p>
                   </a:txBody>
@@ -15506,7 +15810,7 @@
                           <a:ea typeface="Arial"/>
                           <a:cs typeface="Arial"/>
                         </a:rPr>
-                        <a:t>0,75</a:t>
+                        <a:t>0,60</a:t>
                       </a:r>
                     </a:p>
                   </a:txBody>
@@ -15517,158 +15821,6 @@
                   </a:tcPr>
                 </a:tc>
               </a:tr>
-              <a:tr h="502920">
-                <a:tc>
-                  <a:txBody>
-                    <a:bodyPr/>
-                    <a:lstStyle/>
-                    <a:p>
-                      <a:pPr algn="l"/>
-                      <a:r>
-                        <a:rPr sz="1300" b="0">
-                          <a:solidFill>
-                            <a:srgbClr val="163047"/>
-                          </a:solidFill>
-                          <a:latin typeface="Arial"/>
-                          <a:ea typeface="Arial"/>
-                          <a:cs typeface="Arial"/>
-                        </a:rPr>
-                        <a:t>Giữ nguyên (không mô hình)</a:t>
-                      </a:r>
-                    </a:p>
-                  </a:txBody>
-                  <a:tcPr marL="91440" marR="91440" marT="45720" marB="45720" anchor="ctr">
-                    <a:solidFill>
-                      <a:srgbClr val="FFFFFF"/>
-                    </a:solidFill>
-                  </a:tcPr>
-                </a:tc>
-                <a:tc>
-                  <a:txBody>
-                    <a:bodyPr/>
-                    <a:lstStyle/>
-                    <a:p>
-                      <a:pPr algn="l"/>
-                      <a:r>
-                        <a:rPr sz="1300" b="0">
-                          <a:solidFill>
-                            <a:srgbClr val="163047"/>
-                          </a:solidFill>
-                          <a:latin typeface="Arial"/>
-                          <a:ea typeface="Arial"/>
-                          <a:cs typeface="Arial"/>
-                        </a:rPr>
-                        <a:t>–</a:t>
-                      </a:r>
-                    </a:p>
-                  </a:txBody>
-                  <a:tcPr marL="91440" marR="91440" marT="45720" marB="45720" anchor="ctr">
-                    <a:solidFill>
-                      <a:srgbClr val="FFFFFF"/>
-                    </a:solidFill>
-                  </a:tcPr>
-                </a:tc>
-                <a:tc>
-                  <a:txBody>
-                    <a:bodyPr/>
-                    <a:lstStyle/>
-                    <a:p>
-                      <a:pPr algn="l"/>
-                      <a:r>
-                        <a:rPr sz="1300" b="0">
-                          <a:solidFill>
-                            <a:srgbClr val="163047"/>
-                          </a:solidFill>
-                          <a:latin typeface="Arial"/>
-                          <a:ea typeface="Arial"/>
-                          <a:cs typeface="Arial"/>
-                        </a:rPr>
-                        <a:t>2,54</a:t>
-                      </a:r>
-                    </a:p>
-                  </a:txBody>
-                  <a:tcPr marL="91440" marR="91440" marT="45720" marB="45720" anchor="ctr">
-                    <a:solidFill>
-                      <a:srgbClr val="FFFFFF"/>
-                    </a:solidFill>
-                  </a:tcPr>
-                </a:tc>
-                <a:tc>
-                  <a:txBody>
-                    <a:bodyPr/>
-                    <a:lstStyle/>
-                    <a:p>
-                      <a:pPr algn="l"/>
-                      <a:r>
-                        <a:rPr sz="1300" b="0">
-                          <a:solidFill>
-                            <a:srgbClr val="163047"/>
-                          </a:solidFill>
-                          <a:latin typeface="Arial"/>
-                          <a:ea typeface="Arial"/>
-                          <a:cs typeface="Arial"/>
-                        </a:rPr>
-                        <a:t>1,48</a:t>
-                      </a:r>
-                    </a:p>
-                  </a:txBody>
-                  <a:tcPr marL="91440" marR="91440" marT="45720" marB="45720" anchor="ctr">
-                    <a:solidFill>
-                      <a:srgbClr val="FFFFFF"/>
-                    </a:solidFill>
-                  </a:tcPr>
-                </a:tc>
-                <a:tc>
-                  <a:txBody>
-                    <a:bodyPr/>
-                    <a:lstStyle/>
-                    <a:p>
-                      <a:pPr algn="l"/>
-                      <a:r>
-                        <a:rPr sz="1300" b="0">
-                          <a:solidFill>
-                            <a:srgbClr val="163047"/>
-                          </a:solidFill>
-                          <a:latin typeface="Arial"/>
-                          <a:ea typeface="Arial"/>
-                          <a:cs typeface="Arial"/>
-                        </a:rPr>
-                        <a:t>0,99</a:t>
-                      </a:r>
-                    </a:p>
-                  </a:txBody>
-                  <a:tcPr marL="91440" marR="91440" marT="45720" marB="45720" anchor="ctr">
-                    <a:solidFill>
-                      <a:srgbClr val="FFFFFF"/>
-                    </a:solidFill>
-                  </a:tcPr>
-                </a:tc>
-                <a:tc>
-                  <a:txBody>
-                    <a:bodyPr/>
-                    <a:lstStyle/>
-                    <a:p>
-                      <a:pPr algn="l"/>
-                      <a:r>
-                        <a:rPr sz="1300" b="1">
-                          <a:solidFill>
-                            <a:srgbClr val="0D6E56"/>
-                          </a:solidFill>
-                          <a:latin typeface="Arial"/>
-                          <a:ea typeface="Arial"/>
-                          <a:cs typeface="Arial"/>
-                        </a:rPr>
-                        <a:t>0,60</a:t>
-                      </a:r>
-                    </a:p>
-                  </a:txBody>
-                  <a:tcPr marL="91440" marR="91440" marT="45720" marB="45720" anchor="ctr">
-                    <a:solidFill>
-                      <a:srgbClr val="FFFFFF"/>
-                    </a:solidFill>
-                  </a:tcPr>
-                </a:tc>
-              </a:tr>
             </a:tbl>
           </a:graphicData>
         </a:graphic>
@@ -15689,7 +15841,7 @@
         </p:nvSpPr>
         <p:spPr>
           <a:xfrm>
-            <a:off x="621792" y="3977639"/>
+            <a:off x="621792" y="4343400"/>
             <a:ext cx="6766560" cy="1280160"/>
           </a:xfrm>
           <a:prstGeom prst="rect">
@@ -15962,7 +16114,7 @@
                 <a:ea typeface="Arial"/>
                 <a:cs typeface="Arial"/>
               </a:rPr>
-              <a:t>Bộ lọc Kalman chỉ thấp hơn SambaMixer khi biết mọi lần xả trước (0,80 %); giữ nguyên lần đo trước cũng đạt 0,60 %. Biến thể κ: 0,82 % khi đo mỗi 0,05L, chưa lặp lại trên kiểm định chéo.</a:t>
+              <a:t>Mô hình học cập nhật từ lần đo gần nhất: 0,63 % khi đo 8 lần mỗi cell, 0,40 % khi đo mỗi 0,1L, thấp hơn SambaMixer trên cả ba cell. Bộ lọc Kalman chỉ thấp hơn khi biết mọi lần xả trước (0,80 %).</a:t>
             </a:r>
           </a:p>
         </p:txBody>
@@ -16281,7 +16433,7 @@
                 <a:ea typeface="Arial"/>
                 <a:cs typeface="Arial"/>
               </a:rPr>
-              <a:t>Đo thưa: bộ lọc thấp hơn không đo ở 46/48 và thấp hơn giữ nguyên ở 48/48 trường hợp bộ × mức nhãn × lịch đo. Biết mọi lần xả trước: giữ nguyên thấp nhất ở 23/25 trường hợp</a:t>
+              <a:t>Đo thưa: mô hình cập nhật thấp hơn bộ lọc Kalman ở 47/48 và thấp hơn giữ nguyên ở 48/48 trường hợp bộ × mức nhãn × lịch đo. Biết mọi lần xả trước: thấp hơn giữ nguyên ở 12/16</a:t>
             </a:r>
           </a:p>
         </p:txBody>
@@ -17835,7 +17987,7 @@
                 <a:ea typeface="Arial"/>
                 <a:cs typeface="Arial"/>
               </a:rPr>
-              <a:t>NASA-L: chỉ thấp hơn SambaMixer khi biết mọi lần xả trước (0,80 %; giữ nguyên: 0,60 %)</a:t>
+              <a:t>NASA-L: đo thêm cell 8 lần, mô hình cập nhật cho 0,63 %, thấp hơn 0,96 % của SambaMixer</a:t>
             </a:r>
           </a:p>
         </p:txBody>

</xml_diff>